<commit_message>
Charters Towers August report is the lead example in the landing page and manager deck
Co-Authored-By: Claude Fable 5.1 <noreply@anthropic.com>
</commit_message>
<xml_diff>
--- a/PQ_Report_Generator_Overview_for_Managers.pptx
+++ b/PQ_Report_Generator_Overview_for_Managers.pptx
@@ -3264,7 +3264,7 @@
                   <a:srgbClr val="01485C"/>
                 </a:solidFill>
               </a:rPr>
-              <a:t>The ward report — one analyser, one ward</a:t>
+              <a:t>The monthly report — Charters Towers, August 2026</a:t>
             </a:r>
           </a:p>
         </p:txBody>
@@ -3322,7 +3322,7 @@
       </p:sp>
       <p:pic>
         <p:nvPicPr>
-          <p:cNvPr id="20" name="Picture 19" descr="ward_p1.png"/>
+          <p:cNvPr id="20" name="Picture 19" descr="cth_p1.png"/>
           <p:cNvPicPr>
             <a:picLocks noChangeAspect="1"/>
           </p:cNvPicPr>
@@ -3389,7 +3389,7 @@
       </p:sp>
       <p:pic>
         <p:nvPicPr>
-          <p:cNvPr id="22" name="Picture 21" descr="ward_p2.png"/>
+          <p:cNvPr id="22" name="Picture 21" descr="cth_p2.png"/>
           <p:cNvPicPr>
             <a:picLocks noChangeAspect="1"/>
           </p:cNvPicPr>
@@ -3449,7 +3449,7 @@
                   <a:srgbClr val="5F7178"/>
                 </a:solidFill>
               </a:rPr>
-              <a:t>Page 2: cartridges, error mix, staff</a:t>
+              <a:t>Page 2: cartridges and error mix per analyser</a:t>
             </a:r>
           </a:p>
         </p:txBody>
@@ -3487,7 +3487,7 @@
                   <a:srgbClr val="01485C"/>
                 </a:solidFill>
               </a:rPr>
-              <a:t>What the ward manager gets</a:t>
+              <a:t>What the site gets each month</a:t>
             </a:r>
           </a:p>
           <a:p>
@@ -3502,7 +3502,7 @@
                   <a:srgbClr val="17272E"/>
                 </a:solidFill>
               </a:rPr>
-              <a:t>A monthly snapshot: error rate, simulator and ceramic checks, top error, staff flagged this month, recurring alerts.</a:t>
+              <a:t>A monthly snapshot: error rate, simulator and ceramic checks per analyser, top error, staff flagged this month, recurring alerts.</a:t>
             </a:r>
           </a:p>
           <a:p>
@@ -3547,7 +3547,7 @@
                   <a:srgbClr val="17272E"/>
                 </a:solidFill>
               </a:rPr>
-              <a:t>Twenty-four large hospitals get one of these per ward; smaller sites get one report covering all their analysers.</a:t>
+              <a:t>Smaller sites get one report covering all their analysers; the twenty-four largest hospitals get one per ward, plus a site overview.</a:t>
             </a:r>
           </a:p>
         </p:txBody>

</xml_diff>

<commit_message>
Manager deck: all five pages of the Charters Towers report explained across three slides
Co-Authored-By: Claude Fable 5.1 <noreply@anthropic.com>
</commit_message>
<xml_diff>
--- a/PQ_Report_Generator_Overview_for_Managers.pptx
+++ b/PQ_Report_Generator_Overview_for_Managers.pptx
@@ -13,6 +13,8 @@
     <p:sldId id="261" r:id="rId12"/>
     <p:sldId id="262" r:id="rId13"/>
     <p:sldId id="263" r:id="rId14"/>
+    <p:sldId id="264" r:id="rId15"/>
+    <p:sldId id="265" r:id="rId16"/>
   </p:sldIdLst>
   <p:notesMasterIdLst>
     <p:notesMasterId r:id="rId19"/>
@@ -1365,6 +1367,761 @@
 </p:sld>
 </file>
 
+<file path=ppt/slides/slide10.xml><?xml version="1.0" encoding="utf-8"?>
+<p:sld xmlns:a="http://schemas.openxmlformats.org/drawingml/2006/main" xmlns:p="http://schemas.openxmlformats.org/presentationml/2006/main" xmlns:r="http://schemas.openxmlformats.org/officeDocument/2006/relationships">
+  <p:cSld>
+    <p:spTree>
+      <p:nvGrpSpPr>
+        <p:cNvPr id="1" name=""/>
+        <p:cNvGrpSpPr/>
+        <p:nvPr/>
+      </p:nvGrpSpPr>
+      <p:grpSpPr/>
+      <p:sp>
+        <p:nvSpPr>
+          <p:cNvPr id="12" name="Shape 7"/>
+          <p:cNvSpPr/>
+          <p:nvPr/>
+        </p:nvSpPr>
+        <p:spPr>
+          <a:xfrm>
+            <a:off x="0" y="6793992"/>
+            <a:ext cx="2040636" cy="64008"/>
+          </a:xfrm>
+          <a:prstGeom prst="rect">
+            <a:avLst/>
+          </a:prstGeom>
+          <a:solidFill>
+            <a:srgbClr val="01485C"/>
+          </a:solidFill>
+          <a:ln/>
+        </p:spPr>
+        <p:txBody>
+          <a:bodyPr/>
+          <a:p/>
+        </p:txBody>
+      </p:sp>
+      <p:sp>
+        <p:nvSpPr>
+          <p:cNvPr id="13" name="Shape 8"/>
+          <p:cNvSpPr/>
+          <p:nvPr/>
+        </p:nvSpPr>
+        <p:spPr>
+          <a:xfrm>
+            <a:off x="2031492" y="6793992"/>
+            <a:ext cx="2040636" cy="64008"/>
+          </a:xfrm>
+          <a:prstGeom prst="rect">
+            <a:avLst/>
+          </a:prstGeom>
+          <a:solidFill>
+            <a:srgbClr val="146175"/>
+          </a:solidFill>
+          <a:ln/>
+        </p:spPr>
+        <p:txBody>
+          <a:bodyPr/>
+          <a:p/>
+        </p:txBody>
+      </p:sp>
+      <p:sp>
+        <p:nvSpPr>
+          <p:cNvPr id="14" name="Shape 9"/>
+          <p:cNvSpPr/>
+          <p:nvPr/>
+        </p:nvSpPr>
+        <p:spPr>
+          <a:xfrm>
+            <a:off x="4062984" y="6793992"/>
+            <a:ext cx="2040636" cy="64008"/>
+          </a:xfrm>
+          <a:prstGeom prst="rect">
+            <a:avLst/>
+          </a:prstGeom>
+          <a:solidFill>
+            <a:srgbClr val="11B5AE"/>
+          </a:solidFill>
+          <a:ln/>
+        </p:spPr>
+        <p:txBody>
+          <a:bodyPr/>
+          <a:p/>
+        </p:txBody>
+      </p:sp>
+      <p:sp>
+        <p:nvSpPr>
+          <p:cNvPr id="15" name="Shape 10"/>
+          <p:cNvSpPr/>
+          <p:nvPr/>
+        </p:nvSpPr>
+        <p:spPr>
+          <a:xfrm>
+            <a:off x="6094476" y="6793992"/>
+            <a:ext cx="2040636" cy="64008"/>
+          </a:xfrm>
+          <a:prstGeom prst="rect">
+            <a:avLst/>
+          </a:prstGeom>
+          <a:solidFill>
+            <a:srgbClr val="6CCAD4"/>
+          </a:solidFill>
+          <a:ln/>
+        </p:spPr>
+        <p:txBody>
+          <a:bodyPr/>
+          <a:p/>
+        </p:txBody>
+      </p:sp>
+      <p:sp>
+        <p:nvSpPr>
+          <p:cNvPr id="16" name="Shape 11"/>
+          <p:cNvSpPr/>
+          <p:nvPr/>
+        </p:nvSpPr>
+        <p:spPr>
+          <a:xfrm>
+            <a:off x="8125968" y="6793992"/>
+            <a:ext cx="2040636" cy="64008"/>
+          </a:xfrm>
+          <a:prstGeom prst="rect">
+            <a:avLst/>
+          </a:prstGeom>
+          <a:solidFill>
+            <a:srgbClr val="7FC04C"/>
+          </a:solidFill>
+          <a:ln/>
+        </p:spPr>
+        <p:txBody>
+          <a:bodyPr/>
+          <a:p/>
+        </p:txBody>
+      </p:sp>
+      <p:sp>
+        <p:nvSpPr>
+          <p:cNvPr id="17" name="Shape 12"/>
+          <p:cNvSpPr/>
+          <p:nvPr/>
+        </p:nvSpPr>
+        <p:spPr>
+          <a:xfrm>
+            <a:off x="10157460" y="6793992"/>
+            <a:ext cx="2040636" cy="64008"/>
+          </a:xfrm>
+          <a:prstGeom prst="rect">
+            <a:avLst/>
+          </a:prstGeom>
+          <a:solidFill>
+            <a:srgbClr val="E1DD57"/>
+          </a:solidFill>
+          <a:ln/>
+        </p:spPr>
+        <p:txBody>
+          <a:bodyPr/>
+          <a:p/>
+        </p:txBody>
+      </p:sp>
+      <p:sp>
+        <p:nvSpPr>
+          <p:cNvPr id="18" name="TextBox 17"/>
+          <p:cNvSpPr txBox="1"/>
+          <p:nvPr/>
+        </p:nvSpPr>
+        <p:spPr>
+          <a:xfrm>
+            <a:off x="548640" y="320040"/>
+            <a:ext cx="11064240" cy="685800"/>
+          </a:xfrm>
+          <a:prstGeom prst="rect">
+            <a:avLst/>
+          </a:prstGeom>
+          <a:noFill/>
+        </p:spPr>
+        <p:txBody>
+          <a:bodyPr wrap="none">
+            <a:spAutoFit/>
+          </a:bodyPr>
+          <a:lstStyle/>
+          <a:p>
+            <a:r>
+              <a:rPr sz="3000" b="1">
+                <a:solidFill>
+                  <a:srgbClr val="01485C"/>
+                </a:solidFill>
+              </a:rPr>
+              <a:t>Getting the reports for your site</a:t>
+            </a:r>
+          </a:p>
+        </p:txBody>
+      </p:sp>
+      <p:sp>
+        <p:nvSpPr>
+          <p:cNvPr id="19" name="Rounded Rectangle 18"/>
+          <p:cNvSpPr/>
+          <p:nvPr/>
+        </p:nvSpPr>
+        <p:spPr>
+          <a:xfrm>
+            <a:off x="548640" y="1280160"/>
+            <a:ext cx="5440680" cy="2057400"/>
+          </a:xfrm>
+          <a:prstGeom prst="roundRect">
+            <a:avLst>
+              <a:gd name="adj" fmla="val 8000"/>
+            </a:avLst>
+          </a:prstGeom>
+          <a:solidFill>
+            <a:srgbClr val="E5F2F0"/>
+          </a:solidFill>
+          <a:ln>
+            <a:noFill/>
+          </a:ln>
+        </p:spPr>
+        <p:style>
+          <a:lnRef idx="1">
+            <a:schemeClr val="accent1"/>
+          </a:lnRef>
+          <a:fillRef idx="3">
+            <a:schemeClr val="accent1"/>
+          </a:fillRef>
+          <a:effectRef idx="2">
+            <a:schemeClr val="accent1"/>
+          </a:effectRef>
+          <a:fontRef idx="minor">
+            <a:schemeClr val="lt1"/>
+          </a:fontRef>
+        </p:style>
+        <p:txBody>
+          <a:bodyPr rtlCol="0" anchor="ctr"/>
+          <a:lstStyle/>
+          <a:p>
+            <a:pPr algn="ctr"/>
+          </a:p>
+        </p:txBody>
+      </p:sp>
+      <p:sp>
+        <p:nvSpPr>
+          <p:cNvPr id="20" name="TextBox 19"/>
+          <p:cNvSpPr txBox="1"/>
+          <p:nvPr/>
+        </p:nvSpPr>
+        <p:spPr>
+          <a:xfrm>
+            <a:off x="777240" y="1417319"/>
+            <a:ext cx="4983480" cy="457200"/>
+          </a:xfrm>
+          <a:prstGeom prst="rect">
+            <a:avLst/>
+          </a:prstGeom>
+          <a:noFill/>
+        </p:spPr>
+        <p:txBody>
+          <a:bodyPr wrap="square">
+            <a:spAutoFit/>
+          </a:bodyPr>
+          <a:lstStyle/>
+          <a:p>
+            <a:pPr algn="l">
+              <a:spcAft>
+                <a:spcPts val="600"/>
+              </a:spcAft>
+            </a:pPr>
+            <a:r>
+              <a:rPr sz="1500" b="1">
+                <a:solidFill>
+                  <a:srgbClr val="01485C"/>
+                </a:solidFill>
+              </a:rPr>
+              <a:t>1.  Ask the PoC team</a:t>
+            </a:r>
+          </a:p>
+        </p:txBody>
+      </p:sp>
+      <p:sp>
+        <p:nvSpPr>
+          <p:cNvPr id="21" name="TextBox 20"/>
+          <p:cNvSpPr txBox="1"/>
+          <p:nvPr/>
+        </p:nvSpPr>
+        <p:spPr>
+          <a:xfrm>
+            <a:off x="777240" y="1847088"/>
+            <a:ext cx="4983480" cy="1417320"/>
+          </a:xfrm>
+          <a:prstGeom prst="rect">
+            <a:avLst/>
+          </a:prstGeom>
+          <a:noFill/>
+        </p:spPr>
+        <p:txBody>
+          <a:bodyPr wrap="square">
+            <a:spAutoFit/>
+          </a:bodyPr>
+          <a:lstStyle/>
+          <a:p>
+            <a:pPr algn="l">
+              <a:spcAft>
+                <a:spcPts val="600"/>
+              </a:spcAft>
+            </a:pPr>
+            <a:r>
+              <a:rPr sz="1200" b="0">
+                <a:solidFill>
+                  <a:srgbClr val="17272E"/>
+                </a:solidFill>
+              </a:rPr>
+              <a:t>Reports are generated centrally each month from the middleware exports and distributed by HHS folder.</a:t>
+            </a:r>
+          </a:p>
+        </p:txBody>
+      </p:sp>
+      <p:sp>
+        <p:nvSpPr>
+          <p:cNvPr id="22" name="Rounded Rectangle 21"/>
+          <p:cNvSpPr/>
+          <p:nvPr/>
+        </p:nvSpPr>
+        <p:spPr>
+          <a:xfrm>
+            <a:off x="6172200" y="1280160"/>
+            <a:ext cx="5440680" cy="2057400"/>
+          </a:xfrm>
+          <a:prstGeom prst="roundRect">
+            <a:avLst>
+              <a:gd name="adj" fmla="val 8000"/>
+            </a:avLst>
+          </a:prstGeom>
+          <a:solidFill>
+            <a:srgbClr val="E5F2F0"/>
+          </a:solidFill>
+          <a:ln>
+            <a:noFill/>
+          </a:ln>
+        </p:spPr>
+        <p:style>
+          <a:lnRef idx="1">
+            <a:schemeClr val="accent1"/>
+          </a:lnRef>
+          <a:fillRef idx="3">
+            <a:schemeClr val="accent1"/>
+          </a:fillRef>
+          <a:effectRef idx="2">
+            <a:schemeClr val="accent1"/>
+          </a:effectRef>
+          <a:fontRef idx="minor">
+            <a:schemeClr val="lt1"/>
+          </a:fontRef>
+        </p:style>
+        <p:txBody>
+          <a:bodyPr rtlCol="0" anchor="ctr"/>
+          <a:lstStyle/>
+          <a:p>
+            <a:pPr algn="ctr"/>
+          </a:p>
+        </p:txBody>
+      </p:sp>
+      <p:sp>
+        <p:nvSpPr>
+          <p:cNvPr id="23" name="TextBox 22"/>
+          <p:cNvSpPr txBox="1"/>
+          <p:nvPr/>
+        </p:nvSpPr>
+        <p:spPr>
+          <a:xfrm>
+            <a:off x="6400800" y="1417319"/>
+            <a:ext cx="4983480" cy="457200"/>
+          </a:xfrm>
+          <a:prstGeom prst="rect">
+            <a:avLst/>
+          </a:prstGeom>
+          <a:noFill/>
+        </p:spPr>
+        <p:txBody>
+          <a:bodyPr wrap="square">
+            <a:spAutoFit/>
+          </a:bodyPr>
+          <a:lstStyle/>
+          <a:p>
+            <a:pPr algn="l">
+              <a:spcAft>
+                <a:spcPts val="600"/>
+              </a:spcAft>
+            </a:pPr>
+            <a:r>
+              <a:rPr sz="1500" b="1">
+                <a:solidFill>
+                  <a:srgbClr val="01485C"/>
+                </a:solidFill>
+              </a:rPr>
+              <a:t>2.  Tell us your wards</a:t>
+            </a:r>
+          </a:p>
+        </p:txBody>
+      </p:sp>
+      <p:sp>
+        <p:nvSpPr>
+          <p:cNvPr id="24" name="TextBox 23"/>
+          <p:cNvSpPr txBox="1"/>
+          <p:nvPr/>
+        </p:nvSpPr>
+        <p:spPr>
+          <a:xfrm>
+            <a:off x="6400800" y="1847088"/>
+            <a:ext cx="4983480" cy="1417320"/>
+          </a:xfrm>
+          <a:prstGeom prst="rect">
+            <a:avLst/>
+          </a:prstGeom>
+          <a:noFill/>
+        </p:spPr>
+        <p:txBody>
+          <a:bodyPr wrap="square">
+            <a:spAutoFit/>
+          </a:bodyPr>
+          <a:lstStyle/>
+          <a:p>
+            <a:pPr algn="l">
+              <a:spcAft>
+                <a:spcPts val="600"/>
+              </a:spcAft>
+            </a:pPr>
+            <a:r>
+              <a:rPr sz="1200" b="0">
+                <a:solidFill>
+                  <a:srgbClr val="17272E"/>
+                </a:solidFill>
+              </a:rPr>
+              <a:t>Large sites get one report per ward. If a ward name or split is wrong, it is a one-line change.</a:t>
+            </a:r>
+          </a:p>
+        </p:txBody>
+      </p:sp>
+      <p:sp>
+        <p:nvSpPr>
+          <p:cNvPr id="25" name="Rounded Rectangle 24"/>
+          <p:cNvSpPr/>
+          <p:nvPr/>
+        </p:nvSpPr>
+        <p:spPr>
+          <a:xfrm>
+            <a:off x="548640" y="3520440"/>
+            <a:ext cx="5440680" cy="2057400"/>
+          </a:xfrm>
+          <a:prstGeom prst="roundRect">
+            <a:avLst>
+              <a:gd name="adj" fmla="val 8000"/>
+            </a:avLst>
+          </a:prstGeom>
+          <a:solidFill>
+            <a:srgbClr val="E5F2F0"/>
+          </a:solidFill>
+          <a:ln>
+            <a:noFill/>
+          </a:ln>
+        </p:spPr>
+        <p:style>
+          <a:lnRef idx="1">
+            <a:schemeClr val="accent1"/>
+          </a:lnRef>
+          <a:fillRef idx="3">
+            <a:schemeClr val="accent1"/>
+          </a:fillRef>
+          <a:effectRef idx="2">
+            <a:schemeClr val="accent1"/>
+          </a:effectRef>
+          <a:fontRef idx="minor">
+            <a:schemeClr val="lt1"/>
+          </a:fontRef>
+        </p:style>
+        <p:txBody>
+          <a:bodyPr rtlCol="0" anchor="ctr"/>
+          <a:lstStyle/>
+          <a:p>
+            <a:pPr algn="ctr"/>
+          </a:p>
+        </p:txBody>
+      </p:sp>
+      <p:sp>
+        <p:nvSpPr>
+          <p:cNvPr id="26" name="TextBox 25"/>
+          <p:cNvSpPr txBox="1"/>
+          <p:nvPr/>
+        </p:nvSpPr>
+        <p:spPr>
+          <a:xfrm>
+            <a:off x="777240" y="3657600"/>
+            <a:ext cx="4983480" cy="457200"/>
+          </a:xfrm>
+          <a:prstGeom prst="rect">
+            <a:avLst/>
+          </a:prstGeom>
+          <a:noFill/>
+        </p:spPr>
+        <p:txBody>
+          <a:bodyPr wrap="square">
+            <a:spAutoFit/>
+          </a:bodyPr>
+          <a:lstStyle/>
+          <a:p>
+            <a:pPr algn="l">
+              <a:spcAft>
+                <a:spcPts val="600"/>
+              </a:spcAft>
+            </a:pPr>
+            <a:r>
+              <a:rPr sz="1500" b="1">
+                <a:solidFill>
+                  <a:srgbClr val="01485C"/>
+                </a:solidFill>
+              </a:rPr>
+              <a:t>3.  Check the dormant list</a:t>
+            </a:r>
+          </a:p>
+        </p:txBody>
+      </p:sp>
+      <p:sp>
+        <p:nvSpPr>
+          <p:cNvPr id="27" name="TextBox 26"/>
+          <p:cNvSpPr txBox="1"/>
+          <p:nvPr/>
+        </p:nvSpPr>
+        <p:spPr>
+          <a:xfrm>
+            <a:off x="777240" y="4087368"/>
+            <a:ext cx="4983480" cy="1417320"/>
+          </a:xfrm>
+          <a:prstGeom prst="rect">
+            <a:avLst/>
+          </a:prstGeom>
+          <a:noFill/>
+        </p:spPr>
+        <p:txBody>
+          <a:bodyPr wrap="square">
+            <a:spAutoFit/>
+          </a:bodyPr>
+          <a:lstStyle/>
+          <a:p>
+            <a:pPr algn="l">
+              <a:spcAft>
+                <a:spcPts val="600"/>
+              </a:spcAft>
+            </a:pPr>
+            <a:r>
+              <a:rPr sz="1200" b="0">
+                <a:solidFill>
+                  <a:srgbClr val="17272E"/>
+                </a:solidFill>
+              </a:rPr>
+              <a:t>Units on it are candidates for retirement, or should be back in service and maintained.</a:t>
+            </a:r>
+          </a:p>
+        </p:txBody>
+      </p:sp>
+      <p:sp>
+        <p:nvSpPr>
+          <p:cNvPr id="28" name="Rounded Rectangle 27"/>
+          <p:cNvSpPr/>
+          <p:nvPr/>
+        </p:nvSpPr>
+        <p:spPr>
+          <a:xfrm>
+            <a:off x="6172200" y="3520440"/>
+            <a:ext cx="5440680" cy="2057400"/>
+          </a:xfrm>
+          <a:prstGeom prst="roundRect">
+            <a:avLst>
+              <a:gd name="adj" fmla="val 8000"/>
+            </a:avLst>
+          </a:prstGeom>
+          <a:solidFill>
+            <a:srgbClr val="E5F2F0"/>
+          </a:solidFill>
+          <a:ln>
+            <a:noFill/>
+          </a:ln>
+        </p:spPr>
+        <p:style>
+          <a:lnRef idx="1">
+            <a:schemeClr val="accent1"/>
+          </a:lnRef>
+          <a:fillRef idx="3">
+            <a:schemeClr val="accent1"/>
+          </a:fillRef>
+          <a:effectRef idx="2">
+            <a:schemeClr val="accent1"/>
+          </a:effectRef>
+          <a:fontRef idx="minor">
+            <a:schemeClr val="lt1"/>
+          </a:fontRef>
+        </p:style>
+        <p:txBody>
+          <a:bodyPr rtlCol="0" anchor="ctr"/>
+          <a:lstStyle/>
+          <a:p>
+            <a:pPr algn="ctr"/>
+          </a:p>
+        </p:txBody>
+      </p:sp>
+      <p:sp>
+        <p:nvSpPr>
+          <p:cNvPr id="29" name="TextBox 28"/>
+          <p:cNvSpPr txBox="1"/>
+          <p:nvPr/>
+        </p:nvSpPr>
+        <p:spPr>
+          <a:xfrm>
+            <a:off x="6400800" y="3657600"/>
+            <a:ext cx="4983480" cy="457200"/>
+          </a:xfrm>
+          <a:prstGeom prst="rect">
+            <a:avLst/>
+          </a:prstGeom>
+          <a:noFill/>
+        </p:spPr>
+        <p:txBody>
+          <a:bodyPr wrap="square">
+            <a:spAutoFit/>
+          </a:bodyPr>
+          <a:lstStyle/>
+          <a:p>
+            <a:pPr algn="l">
+              <a:spcAft>
+                <a:spcPts val="600"/>
+              </a:spcAft>
+            </a:pPr>
+            <a:r>
+              <a:rPr sz="1500" b="1">
+                <a:solidFill>
+                  <a:srgbClr val="01485C"/>
+                </a:solidFill>
+              </a:rPr>
+              <a:t>4.  Read the summaries first</a:t>
+            </a:r>
+          </a:p>
+        </p:txBody>
+      </p:sp>
+      <p:sp>
+        <p:nvSpPr>
+          <p:cNvPr id="30" name="TextBox 29"/>
+          <p:cNvSpPr txBox="1"/>
+          <p:nvPr/>
+        </p:nvSpPr>
+        <p:spPr>
+          <a:xfrm>
+            <a:off x="6400800" y="4087368"/>
+            <a:ext cx="4983480" cy="1417320"/>
+          </a:xfrm>
+          <a:prstGeom prst="rect">
+            <a:avLst/>
+          </a:prstGeom>
+          <a:noFill/>
+        </p:spPr>
+        <p:txBody>
+          <a:bodyPr wrap="square">
+            <a:spAutoFit/>
+          </a:bodyPr>
+          <a:lstStyle/>
+          <a:p>
+            <a:pPr algn="l">
+              <a:spcAft>
+                <a:spcPts val="600"/>
+              </a:spcAft>
+            </a:pPr>
+            <a:r>
+              <a:rPr sz="1200" b="0">
+                <a:solidFill>
+                  <a:srgbClr val="17272E"/>
+                </a:solidFill>
+              </a:rPr>
+              <a:t>Site Overview for a site lead, Area Summary for an area manager, then the ward reports that need action.</a:t>
+            </a:r>
+          </a:p>
+        </p:txBody>
+      </p:sp>
+      <p:sp>
+        <p:nvSpPr>
+          <p:cNvPr id="31" name="TextBox 30"/>
+          <p:cNvSpPr txBox="1"/>
+          <p:nvPr/>
+        </p:nvSpPr>
+        <p:spPr>
+          <a:xfrm>
+            <a:off x="548640" y="5806440"/>
+            <a:ext cx="11064240" cy="411480"/>
+          </a:xfrm>
+          <a:prstGeom prst="rect">
+            <a:avLst/>
+          </a:prstGeom>
+          <a:noFill/>
+        </p:spPr>
+        <p:txBody>
+          <a:bodyPr wrap="square">
+            <a:spAutoFit/>
+          </a:bodyPr>
+          <a:lstStyle/>
+          <a:p>
+            <a:pPr algn="l">
+              <a:spcAft>
+                <a:spcPts val="600"/>
+              </a:spcAft>
+            </a:pPr>
+            <a:r>
+              <a:rPr sz="1100" b="0">
+                <a:solidFill>
+                  <a:srgbClr val="5F7178"/>
+                </a:solidFill>
+              </a:rPr>
+              <a:t>Support: Pathology Queensland Point of Care team · Chemistry Department, Townsville Group Laboratory</a:t>
+            </a:r>
+          </a:p>
+        </p:txBody>
+      </p:sp>
+      <p:sp>
+        <p:nvSpPr>
+          <p:cNvPr id="32" name="TextBox 31"/>
+          <p:cNvSpPr txBox="1"/>
+          <p:nvPr/>
+        </p:nvSpPr>
+        <p:spPr>
+          <a:xfrm>
+            <a:off x="548640" y="6263640"/>
+            <a:ext cx="11064240" cy="365760"/>
+          </a:xfrm>
+          <a:prstGeom prst="rect">
+            <a:avLst/>
+          </a:prstGeom>
+          <a:noFill/>
+        </p:spPr>
+        <p:txBody>
+          <a:bodyPr wrap="square">
+            <a:spAutoFit/>
+          </a:bodyPr>
+          <a:lstStyle/>
+          <a:p>
+            <a:pPr algn="l">
+              <a:spcAft>
+                <a:spcPts val="600"/>
+              </a:spcAft>
+            </a:pPr>
+            <a:r>
+              <a:rPr sz="1100" b="0">
+                <a:solidFill>
+                  <a:srgbClr val="5F7178"/>
+                </a:solidFill>
+              </a:rPr>
+              <a:t>Conceived, designed and built by Craig MacKenzie · Chemistry Department, Townsville Group Laboratory · Pathology Queensland</a:t>
+            </a:r>
+          </a:p>
+        </p:txBody>
+      </p:sp>
+    </p:spTree>
+  </p:cSld>
+  <p:clrMapOvr>
+    <a:masterClrMapping/>
+  </p:clrMapOvr>
+</p:sld>
+</file>
+
 <file path=ppt/slides/slide2.xml><?xml version="1.0" encoding="utf-8"?>
 <p:sld xmlns:a="http://schemas.openxmlformats.org/drawingml/2006/main" xmlns:p="http://schemas.openxmlformats.org/presentationml/2006/main" xmlns:r="http://schemas.openxmlformats.org/officeDocument/2006/relationships">
   <p:cSld>
@@ -3264,7 +4021,7 @@
                   <a:srgbClr val="01485C"/>
                 </a:solidFill>
               </a:rPr>
-              <a:t>The monthly report — Charters Towers, August 2026</a:t>
+              <a:t>Charters Towers, August 2026 — pages 1–2 of 5</a:t>
             </a:r>
           </a:p>
         </p:txBody>
@@ -3382,7 +4139,7 @@
                   <a:srgbClr val="5F7178"/>
                 </a:solidFill>
               </a:rPr>
-              <a:t>Page 1: snapshot and 12-month trend</a:t>
+              <a:t>Page 1: snapshot and first trend</a:t>
             </a:r>
           </a:p>
         </p:txBody>
@@ -3449,7 +4206,7 @@
                   <a:srgbClr val="5F7178"/>
                 </a:solidFill>
               </a:rPr>
-              <a:t>Page 2: cartridges and error mix per analyser</a:t>
+              <a:t>Page 2: error mix, second trend</a:t>
             </a:r>
           </a:p>
         </p:txBody>
@@ -3487,7 +4244,7 @@
                   <a:srgbClr val="01485C"/>
                 </a:solidFill>
               </a:rPr>
-              <a:t>What the site gets each month</a:t>
+              <a:t>Page 1 — the month at a glance</a:t>
             </a:r>
           </a:p>
           <a:p>
@@ -3502,7 +4259,7 @@
                   <a:srgbClr val="17272E"/>
                 </a:solidFill>
               </a:rPr>
-              <a:t>A monthly snapshot: error rate, simulator and ceramic checks per analyser, top error, staff flagged this month, recurring alerts.</a:t>
+              <a:t>Monthly Snapshot: overall error rate with its performance band (3.6%, Champions); simulator runs per analyser; ceramic cleaning per analyser (here one of two failed); the top error code, flagged when it repeats from the previous month; staff flagged this month (four with 3+ errors); recurring staff alerts.</a:t>
             </a:r>
           </a:p>
           <a:p>
@@ -3517,7 +4274,7 @@
                   <a:srgbClr val="17272E"/>
                 </a:solidFill>
               </a:rPr>
-              <a:t>Two 12-month charts per analyser: the error-rate trend against the performance bands, and cartridges run with the error mix.</a:t>
+              <a:t>Error Rate Trend for the first analyser: twelve months against the colour bands, so a drift is visible before it becomes a problem.</a:t>
             </a:r>
           </a:p>
           <a:p>
@@ -3532,22 +4289,7 @@
                   <a:srgbClr val="17272E"/>
                 </a:solidFill>
               </a:rPr>
-              <a:t>Every cartridge error with the staff member, the code and its likely cause, then a follow-up list of staff with three or more errors.</a:t>
-            </a:r>
-          </a:p>
-          <a:p>
-            <a:pPr algn="l">
-              <a:spcAft>
-                <a:spcPts val="600"/>
-              </a:spcAft>
-            </a:pPr>
-            <a:r>
-              <a:rPr sz="1200" b="0">
-                <a:solidFill>
-                  <a:srgbClr val="17272E"/>
-                </a:solidFill>
-              </a:rPr>
-              <a:t>Smaller sites get one report covering all their analysers; the twenty-four largest hospitals get one per ward, plus a site overview.</a:t>
+              <a:t>Page 2 — Cartridges Run &amp; Error Mix for the same analyser: workload on top, each month’s errors as a percentage split by category (handling, overfilled, underfilled, sample volume and so on), then the trend chart for the second analyser.</a:t>
             </a:r>
           </a:p>
         </p:txBody>
@@ -3780,7 +4522,7 @@
                   <a:srgbClr val="01485C"/>
                 </a:solidFill>
               </a:rPr>
-              <a:t>Summaries for site leads and area managers</a:t>
+              <a:t>Charters Towers, August 2026 — pages 3–4 of 5</a:t>
             </a:r>
           </a:p>
         </p:txBody>
@@ -3838,7 +4580,7 @@
       </p:sp>
       <p:pic>
         <p:nvPicPr>
-          <p:cNvPr id="20" name="Picture 19" descr="site_p1.png"/>
+          <p:cNvPr id="20" name="Picture 19" descr="cth_p3.png"/>
           <p:cNvPicPr>
             <a:picLocks noChangeAspect="1"/>
           </p:cNvPicPr>
@@ -3898,14 +4640,14 @@
                   <a:srgbClr val="5F7178"/>
                 </a:solidFill>
               </a:rPr>
-              <a:t>Site Overview — every ward of a large site on one page</a:t>
+              <a:t>Page 3: performance and QC checks</a:t>
             </a:r>
           </a:p>
         </p:txBody>
       </p:sp>
       <p:pic>
         <p:nvPicPr>
-          <p:cNvPr id="22" name="Picture 21" descr="area_p1.png"/>
+          <p:cNvPr id="22" name="Picture 21" descr="cth_p4.png"/>
           <p:cNvPicPr>
             <a:picLocks noChangeAspect="1"/>
           </p:cNvPicPr>
@@ -3965,7 +4707,7 @@
                   <a:srgbClr val="5F7178"/>
                 </a:solidFill>
               </a:rPr>
-              <a:t>Area Summary — every hospital in the HHS</a:t>
+              <a:t>Page 4: staff follow-up, every error</a:t>
             </a:r>
           </a:p>
         </p:txBody>
@@ -4003,7 +4745,7 @@
                   <a:srgbClr val="01485C"/>
                 </a:solidFill>
               </a:rPr>
-              <a:t>The whole picture on one page</a:t>
+              <a:t>Page 3 — performance and QC compliance</a:t>
             </a:r>
           </a:p>
           <a:p>
@@ -4018,7 +4760,7 @@
                   <a:srgbClr val="17272E"/>
                 </a:solidFill>
               </a:rPr>
-              <a:t>Site Overview: each ward’s analyser with cartridges, errors, error %, performance band, simulator runs and a ceramic pass or fail, plus a site total.</a:t>
+              <a:t>Error mix for the second analyser, then the Performance Summary: cartridges, errors and error rate per analyser with its band, and the site total.</a:t>
             </a:r>
           </a:p>
           <a:p>
@@ -4033,7 +4775,7 @@
                   <a:srgbClr val="17272E"/>
                 </a:solidFill>
               </a:rPr>
-              <a:t>Area Summary: the same figures per hospital across the HHS, an area total, and a table of every analyser that missed simulators or ceramics.</a:t>
+              <a:t>Simulators run per analyser, and the Monthly Ceramic Cleaning check per analyser — FAIL if any analyser is below the three cartridges required.</a:t>
             </a:r>
           </a:p>
           <a:p>
@@ -4048,7 +4790,22 @@
                   <a:srgbClr val="17272E"/>
                 </a:solidFill>
               </a:rPr>
-              <a:t>Both are produced automatically with every run, in the same folder as the reports.</a:t>
+              <a:t>Page 4 — Staff Requiring Follow-up: this month’s staff with three or more errors, with their error count and personal error rate; a Recurring section appears when someone is flagged in consecutive months.</a:t>
+            </a:r>
+          </a:p>
+          <a:p>
+            <a:pPr algn="l">
+              <a:spcAft>
+                <a:spcPts val="600"/>
+              </a:spcAft>
+            </a:pPr>
+            <a:r>
+              <a:rPr sz="1200" b="0">
+                <a:solidFill>
+                  <a:srgbClr val="17272E"/>
+                </a:solidFill>
+              </a:rPr>
+              <a:t>All cartridge errors recorded this month: every event by location and staff member, the code and its likely cause, flagged staff in red — the evidence behind the follow-up list.</a:t>
             </a:r>
           </a:p>
         </p:txBody>
@@ -4281,7 +5038,7 @@
                   <a:srgbClr val="01485C"/>
                 </a:solidFill>
               </a:rPr>
-              <a:t>Dormant analysers — found, left out, listed</a:t>
+              <a:t>Charters Towers, August 2026 — page 5 of 5</a:t>
             </a:r>
           </a:p>
         </p:txBody>
@@ -4339,7 +5096,7 @@
       </p:sp>
       <p:pic>
         <p:nvPicPr>
-          <p:cNvPr id="20" name="Picture 19" descr="dormant_p1.png"/>
+          <p:cNvPr id="20" name="Picture 19" descr="cth_p5_top.png"/>
           <p:cNvPicPr>
             <a:picLocks noChangeAspect="1"/>
           </p:cNvPicPr>
@@ -4354,7 +5111,7 @@
         <p:spPr>
           <a:xfrm>
             <a:off x="548640" y="1143000"/>
-            <a:ext cx="3429521" cy="4846320"/>
+            <a:ext cx="5534103" cy="4846320"/>
           </a:xfrm>
           <a:prstGeom prst="rect">
             <a:avLst/>
@@ -4375,7 +5132,7 @@
         <p:spPr>
           <a:xfrm>
             <a:off x="548640" y="6035040"/>
-            <a:ext cx="3429521" cy="365760"/>
+            <a:ext cx="5534103" cy="365760"/>
           </a:xfrm>
           <a:prstGeom prst="rect">
             <a:avLst/>
@@ -4399,7 +5156,7 @@
                   <a:srgbClr val="5F7178"/>
                 </a:solidFill>
               </a:rPr>
-              <a:t>The dormant-analyser list for August 2026</a:t>
+              <a:t>Page 5: error causes and the 12-month pattern</a:t>
             </a:r>
           </a:p>
         </p:txBody>
@@ -4412,8 +5169,8 @@
         </p:nvSpPr>
         <p:spPr>
           <a:xfrm>
-            <a:off x="4480560" y="1188720"/>
-            <a:ext cx="7132320" cy="4846320"/>
+            <a:off x="6402783" y="1188720"/>
+            <a:ext cx="5210097" cy="4846320"/>
           </a:xfrm>
           <a:prstGeom prst="rect">
             <a:avLst/>
@@ -4437,7 +5194,7 @@
                   <a:srgbClr val="01485C"/>
                 </a:solidFill>
               </a:rPr>
-              <a:t>The four-month rule</a:t>
+              <a:t>Page 5 — understanding the errors</a:t>
             </a:r>
           </a:p>
           <a:p>
@@ -4452,7 +5209,7 @@
                   <a:srgbClr val="17272E"/>
                 </a:solidFill>
               </a:rPr>
-              <a:t>An analyser with no cartridges, no simulator runs and no ceramic cleaning for four consecutive months is dormant: it gets no report and no longer counts against its site’s checks.</a:t>
+              <a:t>Error Type Summary: the month’s error codes with their likely cause and count, the top code flagged when it is a repeat.</a:t>
             </a:r>
           </a:p>
           <a:p>
@@ -4467,7 +5224,7 @@
                   <a:srgbClr val="17272E"/>
                 </a:solidFill>
               </a:rPr>
-              <a:t>One or two quiet months change nothing. The reports exist to catch wards skipping simulators, so nothing is removed early.</a:t>
+              <a:t>Top Error Code Analysis: the device message and a plain-English explanation of each leading code — what the operator saw and what to do about it. Here CODE 95 (operator cancelled before mandatory data was entered) leads for the second time.</a:t>
             </a:r>
           </a:p>
           <a:p>
@@ -4482,7 +5239,7 @@
                   <a:srgbClr val="17272E"/>
                 </a:solidFill>
               </a:rPr>
-              <a:t>Any use brings the unit straight back the next month.</a:t>
+              <a:t>Error Type Trend: the top error type each month for the last twelve, repeats flagged — the difference between a bad month and a habit.</a:t>
             </a:r>
           </a:p>
           <a:p>
@@ -4497,7 +5254,7 @@
                   <a:srgbClr val="17272E"/>
                 </a:solidFill>
               </a:rPr>
-              <a:t>Every run writes the list: hospital, location, serial, months idle and last activity. In August 2026, 163 units — mostly old models sitting beside their replacements — a ready-made retirement list.</a:t>
+              <a:t>A link to the online training resources closes every report.</a:t>
             </a:r>
           </a:p>
         </p:txBody>
@@ -4730,7 +5487,7 @@
                   <a:srgbClr val="01485C"/>
                 </a:solidFill>
               </a:rPr>
-              <a:t>How it protects the data</a:t>
+              <a:t>Summaries for site leads and area managers</a:t>
             </a:r>
           </a:p>
         </p:txBody>
@@ -4743,16 +5500,14 @@
         </p:nvSpPr>
         <p:spPr>
           <a:xfrm>
-            <a:off x="548640" y="1280160"/>
-            <a:ext cx="5440680" cy="2103120"/>
+            <a:off x="9784080" y="384048"/>
+            <a:ext cx="1828800" cy="457200"/>
           </a:xfrm>
           <a:prstGeom prst="roundRect">
-            <a:avLst>
-              <a:gd name="adj" fmla="val 8000"/>
-            </a:avLst>
-          </a:prstGeom>
-          <a:solidFill>
-            <a:srgbClr val="E5F2F0"/>
+            <a:avLst/>
+          </a:prstGeom>
+          <a:solidFill>
+            <a:srgbClr val="01485C"/>
           </a:solidFill>
           <a:ln>
             <a:noFill/>
@@ -4777,19 +5532,56 @@
           <a:lstStyle/>
           <a:p>
             <a:pPr algn="ctr"/>
-          </a:p>
-        </p:txBody>
-      </p:sp>
-      <p:sp>
-        <p:nvSpPr>
-          <p:cNvPr id="20" name="TextBox 19"/>
+            <a:r>
+              <a:rPr sz="1500" b="1">
+                <a:solidFill>
+                  <a:srgbClr val="FFFFFF"/>
+                </a:solidFill>
+              </a:rPr>
+              <a:t>i-STAT</a:t>
+            </a:r>
+          </a:p>
+        </p:txBody>
+      </p:sp>
+      <p:pic>
+        <p:nvPicPr>
+          <p:cNvPr id="20" name="Picture 19" descr="site_p1.png"/>
+          <p:cNvPicPr>
+            <a:picLocks noChangeAspect="1"/>
+          </p:cNvPicPr>
+          <p:nvPr/>
+        </p:nvPicPr>
+        <p:blipFill>
+          <a:blip r:embed="rId2"/>
+          <a:stretch>
+            <a:fillRect/>
+          </a:stretch>
+        </p:blipFill>
+        <p:spPr>
+          <a:xfrm>
+            <a:off x="548640" y="1143000"/>
+            <a:ext cx="3429521" cy="4846320"/>
+          </a:xfrm>
+          <a:prstGeom prst="rect">
+            <a:avLst/>
+          </a:prstGeom>
+          <a:ln>
+            <a:solidFill>
+              <a:srgbClr val="E2E8EA"/>
+            </a:solidFill>
+          </a:ln>
+        </p:spPr>
+      </p:pic>
+      <p:sp>
+        <p:nvSpPr>
+          <p:cNvPr id="21" name="TextBox 20"/>
           <p:cNvSpPr txBox="1"/>
           <p:nvPr/>
         </p:nvSpPr>
         <p:spPr>
           <a:xfrm>
-            <a:off x="777240" y="1417319"/>
-            <a:ext cx="4983480" cy="457200"/>
+            <a:off x="548640" y="6035040"/>
+            <a:ext cx="3429521" cy="365760"/>
           </a:xfrm>
           <a:prstGeom prst="rect">
             <a:avLst/>
@@ -4802,32 +5594,61 @@
           </a:bodyPr>
           <a:lstStyle/>
           <a:p>
-            <a:pPr algn="l">
-              <a:spcAft>
-                <a:spcPts val="600"/>
-              </a:spcAft>
-            </a:pPr>
-            <a:r>
-              <a:rPr sz="1500" b="1">
-                <a:solidFill>
-                  <a:srgbClr val="01485C"/>
-                </a:solidFill>
-              </a:rPr>
-              <a:t>Runs from an encrypted USB drive</a:t>
-            </a:r>
-          </a:p>
-        </p:txBody>
-      </p:sp>
-      <p:sp>
-        <p:nvSpPr>
-          <p:cNvPr id="21" name="TextBox 20"/>
+            <a:pPr algn="ctr">
+              <a:spcAft>
+                <a:spcPts val="600"/>
+              </a:spcAft>
+            </a:pPr>
+            <a:r>
+              <a:rPr sz="1100" b="0">
+                <a:solidFill>
+                  <a:srgbClr val="5F7178"/>
+                </a:solidFill>
+              </a:rPr>
+              <a:t>Site Overview — every ward of a large site on one page</a:t>
+            </a:r>
+          </a:p>
+        </p:txBody>
+      </p:sp>
+      <p:pic>
+        <p:nvPicPr>
+          <p:cNvPr id="22" name="Picture 21" descr="area_p1.png"/>
+          <p:cNvPicPr>
+            <a:picLocks noChangeAspect="1"/>
+          </p:cNvPicPr>
+          <p:nvPr/>
+        </p:nvPicPr>
+        <p:blipFill>
+          <a:blip r:embed="rId3"/>
+          <a:stretch>
+            <a:fillRect/>
+          </a:stretch>
+        </p:blipFill>
+        <p:spPr>
+          <a:xfrm>
+            <a:off x="4206240" y="1143000"/>
+            <a:ext cx="3429521" cy="4846320"/>
+          </a:xfrm>
+          <a:prstGeom prst="rect">
+            <a:avLst/>
+          </a:prstGeom>
+          <a:ln>
+            <a:solidFill>
+              <a:srgbClr val="E2E8EA"/>
+            </a:solidFill>
+          </a:ln>
+        </p:spPr>
+      </p:pic>
+      <p:sp>
+        <p:nvSpPr>
+          <p:cNvPr id="23" name="TextBox 22"/>
           <p:cNvSpPr txBox="1"/>
           <p:nvPr/>
         </p:nvSpPr>
         <p:spPr>
           <a:xfrm>
-            <a:off x="777240" y="1847088"/>
-            <a:ext cx="4983480" cy="1463039"/>
+            <a:off x="4206240" y="6035040"/>
+            <a:ext cx="3429521" cy="365760"/>
           </a:xfrm>
           <a:prstGeom prst="rect">
             <a:avLst/>
@@ -4840,77 +5661,32 @@
           </a:bodyPr>
           <a:lstStyle/>
           <a:p>
-            <a:pPr algn="l">
-              <a:spcAft>
-                <a:spcPts val="600"/>
-              </a:spcAft>
-            </a:pPr>
-            <a:r>
-              <a:rPr sz="1200" b="0">
-                <a:solidFill>
-                  <a:srgbClr val="17272E"/>
-                </a:solidFill>
-              </a:rPr>
-              <a:t>Its own Python runtime, no installation, no admin rights, no changes to the PC. BitLocker To Go encrypts the whole drive.</a:t>
-            </a:r>
-          </a:p>
-        </p:txBody>
-      </p:sp>
-      <p:sp>
-        <p:nvSpPr>
-          <p:cNvPr id="22" name="Rounded Rectangle 21"/>
-          <p:cNvSpPr/>
-          <p:nvPr/>
-        </p:nvSpPr>
-        <p:spPr>
-          <a:xfrm>
-            <a:off x="6172200" y="1280160"/>
-            <a:ext cx="5440680" cy="2103120"/>
-          </a:xfrm>
-          <a:prstGeom prst="roundRect">
-            <a:avLst>
-              <a:gd name="adj" fmla="val 8000"/>
-            </a:avLst>
-          </a:prstGeom>
-          <a:solidFill>
-            <a:srgbClr val="E5F2F0"/>
-          </a:solidFill>
-          <a:ln>
-            <a:noFill/>
-          </a:ln>
-        </p:spPr>
-        <p:style>
-          <a:lnRef idx="1">
-            <a:schemeClr val="accent1"/>
-          </a:lnRef>
-          <a:fillRef idx="3">
-            <a:schemeClr val="accent1"/>
-          </a:fillRef>
-          <a:effectRef idx="2">
-            <a:schemeClr val="accent1"/>
-          </a:effectRef>
-          <a:fontRef idx="minor">
-            <a:schemeClr val="lt1"/>
-          </a:fontRef>
-        </p:style>
-        <p:txBody>
-          <a:bodyPr rtlCol="0" anchor="ctr"/>
-          <a:lstStyle/>
-          <a:p>
-            <a:pPr algn="ctr"/>
-          </a:p>
-        </p:txBody>
-      </p:sp>
-      <p:sp>
-        <p:nvSpPr>
-          <p:cNvPr id="23" name="TextBox 22"/>
+            <a:pPr algn="ctr">
+              <a:spcAft>
+                <a:spcPts val="600"/>
+              </a:spcAft>
+            </a:pPr>
+            <a:r>
+              <a:rPr sz="1100" b="0">
+                <a:solidFill>
+                  <a:srgbClr val="5F7178"/>
+                </a:solidFill>
+              </a:rPr>
+              <a:t>Area Summary — every hospital in the HHS</a:t>
+            </a:r>
+          </a:p>
+        </p:txBody>
+      </p:sp>
+      <p:sp>
+        <p:nvSpPr>
+          <p:cNvPr id="24" name="TextBox 23"/>
           <p:cNvSpPr txBox="1"/>
           <p:nvPr/>
         </p:nvSpPr>
         <p:spPr>
           <a:xfrm>
-            <a:off x="6400800" y="1417319"/>
-            <a:ext cx="4983480" cy="457200"/>
+            <a:off x="8046720" y="1188720"/>
+            <a:ext cx="3566160" cy="4846320"/>
           </a:xfrm>
           <a:prstGeom prst="rect">
             <a:avLst/>
@@ -4934,32 +5710,9 @@
                   <a:srgbClr val="01485C"/>
                 </a:solidFill>
               </a:rPr>
-              <a:t>Offline by enforcement</a:t>
-            </a:r>
-          </a:p>
-        </p:txBody>
-      </p:sp>
-      <p:sp>
-        <p:nvSpPr>
-          <p:cNvPr id="24" name="TextBox 23"/>
-          <p:cNvSpPr txBox="1"/>
-          <p:nvPr/>
-        </p:nvSpPr>
-        <p:spPr>
-          <a:xfrm>
-            <a:off x="6400800" y="1847088"/>
-            <a:ext cx="4983480" cy="1463039"/>
-          </a:xfrm>
-          <a:prstGeom prst="rect">
-            <a:avLst/>
-          </a:prstGeom>
-          <a:noFill/>
-        </p:spPr>
-        <p:txBody>
-          <a:bodyPr wrap="square">
-            <a:spAutoFit/>
-          </a:bodyPr>
-          <a:lstStyle/>
+              <a:t>The whole picture on one page</a:t>
+            </a:r>
+          </a:p>
           <a:p>
             <a:pPr algn="l">
               <a:spcAft>
@@ -4972,115 +5725,9 @@
                   <a:srgbClr val="17272E"/>
                 </a:solidFill>
               </a:rPr>
-              <a:t>All three servers bind to the local machine only, and a runtime guard blocks and logs any attempt to reach the network. Zero outbound connections, ever.</a:t>
-            </a:r>
-          </a:p>
-        </p:txBody>
-      </p:sp>
-      <p:sp>
-        <p:nvSpPr>
-          <p:cNvPr id="25" name="Rounded Rectangle 24"/>
-          <p:cNvSpPr/>
-          <p:nvPr/>
-        </p:nvSpPr>
-        <p:spPr>
-          <a:xfrm>
-            <a:off x="548640" y="3566160"/>
-            <a:ext cx="5440680" cy="2103120"/>
-          </a:xfrm>
-          <a:prstGeom prst="roundRect">
-            <a:avLst>
-              <a:gd name="adj" fmla="val 8000"/>
-            </a:avLst>
-          </a:prstGeom>
-          <a:solidFill>
-            <a:srgbClr val="FDF0E4"/>
-          </a:solidFill>
-          <a:ln>
-            <a:noFill/>
-          </a:ln>
-        </p:spPr>
-        <p:style>
-          <a:lnRef idx="1">
-            <a:schemeClr val="accent1"/>
-          </a:lnRef>
-          <a:fillRef idx="3">
-            <a:schemeClr val="accent1"/>
-          </a:fillRef>
-          <a:effectRef idx="2">
-            <a:schemeClr val="accent1"/>
-          </a:effectRef>
-          <a:fontRef idx="minor">
-            <a:schemeClr val="lt1"/>
-          </a:fontRef>
-        </p:style>
-        <p:txBody>
-          <a:bodyPr rtlCol="0" anchor="ctr"/>
-          <a:lstStyle/>
-          <a:p>
-            <a:pPr algn="ctr"/>
-          </a:p>
-        </p:txBody>
-      </p:sp>
-      <p:sp>
-        <p:nvSpPr>
-          <p:cNvPr id="26" name="TextBox 25"/>
-          <p:cNvSpPr txBox="1"/>
-          <p:nvPr/>
-        </p:nvSpPr>
-        <p:spPr>
-          <a:xfrm>
-            <a:off x="777240" y="3703320"/>
-            <a:ext cx="4983480" cy="457200"/>
-          </a:xfrm>
-          <a:prstGeom prst="rect">
-            <a:avLst/>
-          </a:prstGeom>
-          <a:noFill/>
-        </p:spPr>
-        <p:txBody>
-          <a:bodyPr wrap="square">
-            <a:spAutoFit/>
-          </a:bodyPr>
-          <a:lstStyle/>
-          <a:p>
-            <a:pPr algn="l">
-              <a:spcAft>
-                <a:spcPts val="600"/>
-              </a:spcAft>
-            </a:pPr>
-            <a:r>
-              <a:rPr sz="1500" b="1">
-                <a:solidFill>
-                  <a:srgbClr val="B4540A"/>
-                </a:solidFill>
-              </a:rPr>
-              <a:t>Named staff data encrypted</a:t>
-            </a:r>
-          </a:p>
-        </p:txBody>
-      </p:sp>
-      <p:sp>
-        <p:nvSpPr>
-          <p:cNvPr id="27" name="TextBox 26"/>
-          <p:cNvSpPr txBox="1"/>
-          <p:nvPr/>
-        </p:nvSpPr>
-        <p:spPr>
-          <a:xfrm>
-            <a:off x="777240" y="4133087"/>
-            <a:ext cx="4983480" cy="1463039"/>
-          </a:xfrm>
-          <a:prstGeom prst="rect">
-            <a:avLst/>
-          </a:prstGeom>
-          <a:noFill/>
-        </p:spPr>
-        <p:txBody>
-          <a:bodyPr wrap="square">
-            <a:spAutoFit/>
-          </a:bodyPr>
-          <a:lstStyle/>
+              <a:t>Site Overview: each ward’s analyser with cartridges, errors, error %, performance band, simulator runs and a ceramic pass or fail, plus a site total.</a:t>
+            </a:r>
+          </a:p>
           <a:p>
             <a:pPr algn="l">
               <a:spcAft>
@@ -5093,115 +5740,9 @@
                   <a:srgbClr val="17272E"/>
                 </a:solidFill>
               </a:rPr>
-              <a:t>The rolling staff and device history is AES-encrypted with a password that is never stored. Reports cannot be generated until it is unlocked.</a:t>
-            </a:r>
-          </a:p>
-        </p:txBody>
-      </p:sp>
-      <p:sp>
-        <p:nvSpPr>
-          <p:cNvPr id="28" name="Rounded Rectangle 27"/>
-          <p:cNvSpPr/>
-          <p:nvPr/>
-        </p:nvSpPr>
-        <p:spPr>
-          <a:xfrm>
-            <a:off x="6172200" y="3566160"/>
-            <a:ext cx="5440680" cy="2103120"/>
-          </a:xfrm>
-          <a:prstGeom prst="roundRect">
-            <a:avLst>
-              <a:gd name="adj" fmla="val 8000"/>
-            </a:avLst>
-          </a:prstGeom>
-          <a:solidFill>
-            <a:srgbClr val="E5F2F0"/>
-          </a:solidFill>
-          <a:ln>
-            <a:noFill/>
-          </a:ln>
-        </p:spPr>
-        <p:style>
-          <a:lnRef idx="1">
-            <a:schemeClr val="accent1"/>
-          </a:lnRef>
-          <a:fillRef idx="3">
-            <a:schemeClr val="accent1"/>
-          </a:fillRef>
-          <a:effectRef idx="2">
-            <a:schemeClr val="accent1"/>
-          </a:effectRef>
-          <a:fontRef idx="minor">
-            <a:schemeClr val="lt1"/>
-          </a:fontRef>
-        </p:style>
-        <p:txBody>
-          <a:bodyPr rtlCol="0" anchor="ctr"/>
-          <a:lstStyle/>
-          <a:p>
-            <a:pPr algn="ctr"/>
-          </a:p>
-        </p:txBody>
-      </p:sp>
-      <p:sp>
-        <p:nvSpPr>
-          <p:cNvPr id="29" name="TextBox 28"/>
-          <p:cNvSpPr txBox="1"/>
-          <p:nvPr/>
-        </p:nvSpPr>
-        <p:spPr>
-          <a:xfrm>
-            <a:off x="6400800" y="3703320"/>
-            <a:ext cx="4983480" cy="457200"/>
-          </a:xfrm>
-          <a:prstGeom prst="rect">
-            <a:avLst/>
-          </a:prstGeom>
-          <a:noFill/>
-        </p:spPr>
-        <p:txBody>
-          <a:bodyPr wrap="square">
-            <a:spAutoFit/>
-          </a:bodyPr>
-          <a:lstStyle/>
-          <a:p>
-            <a:pPr algn="l">
-              <a:spcAft>
-                <a:spcPts val="600"/>
-              </a:spcAft>
-            </a:pPr>
-            <a:r>
-              <a:rPr sz="1500" b="1">
-                <a:solidFill>
-                  <a:srgbClr val="01485C"/>
-                </a:solidFill>
-              </a:rPr>
-              <a:t>Controlled roll-out</a:t>
-            </a:r>
-          </a:p>
-        </p:txBody>
-      </p:sp>
-      <p:sp>
-        <p:nvSpPr>
-          <p:cNvPr id="30" name="TextBox 29"/>
-          <p:cNvSpPr txBox="1"/>
-          <p:nvPr/>
-        </p:nvSpPr>
-        <p:spPr>
-          <a:xfrm>
-            <a:off x="6400800" y="4133087"/>
-            <a:ext cx="4983480" cy="1463039"/>
-          </a:xfrm>
-          <a:prstGeom prst="rect">
-            <a:avLst/>
-          </a:prstGeom>
-          <a:noFill/>
-        </p:spPr>
-        <p:txBody>
-          <a:bodyPr wrap="square">
-            <a:spAutoFit/>
-          </a:bodyPr>
-          <a:lstStyle/>
+              <a:t>Area Summary: the same figures per hospital across the HHS, an area total, and a table of every analyser that missed simulators or ceramics.</a:t>
+            </a:r>
+          </a:p>
           <a:p>
             <a:pPr algn="l">
               <a:spcAft>
@@ -5214,52 +5755,14 @@
                   <a:srgbClr val="17272E"/>
                 </a:solidFill>
               </a:rPr>
-              <a:t>It runs only on PCs approved by the PoC lead, reviewed on the 12-month QIS cycle, with an audit trail of every launch and every report generated.</a:t>
-            </a:r>
-          </a:p>
-        </p:txBody>
-      </p:sp>
-      <p:sp>
-        <p:nvSpPr>
-          <p:cNvPr id="31" name="TextBox 30"/>
-          <p:cNvSpPr txBox="1"/>
-          <p:nvPr/>
-        </p:nvSpPr>
-        <p:spPr>
-          <a:xfrm>
-            <a:off x="548640" y="5806440"/>
-            <a:ext cx="11064240" cy="411480"/>
-          </a:xfrm>
-          <a:prstGeom prst="rect">
-            <a:avLst/>
-          </a:prstGeom>
-          <a:noFill/>
-        </p:spPr>
-        <p:txBody>
-          <a:bodyPr wrap="square">
-            <a:spAutoFit/>
-          </a:bodyPr>
-          <a:lstStyle/>
-          <a:p>
-            <a:pPr algn="l">
-              <a:spcAft>
-                <a:spcPts val="600"/>
-              </a:spcAft>
-            </a:pPr>
-            <a:r>
-              <a:rPr sz="1100" b="0">
-                <a:solidFill>
-                  <a:srgbClr val="5F7178"/>
-                </a:solidFill>
-              </a:rPr>
-              <a:t>Full detail for IT: SECURITY_README.md on the drive and the Security Briefing deck.</a:t>
-            </a:r>
-          </a:p>
-        </p:txBody>
-      </p:sp>
-      <p:sp>
-        <p:nvSpPr>
-          <p:cNvPr id="32" name="TextBox 31"/>
+              <a:t>Both are produced automatically with every run, in the same folder as the reports.</a:t>
+            </a:r>
+          </a:p>
+        </p:txBody>
+      </p:sp>
+      <p:sp>
+        <p:nvSpPr>
+          <p:cNvPr id="25" name="TextBox 24"/>
           <p:cNvSpPr txBox="1"/>
           <p:nvPr/>
         </p:nvSpPr>
@@ -5485,7 +5988,7 @@
                   <a:srgbClr val="01485C"/>
                 </a:solidFill>
               </a:rPr>
-              <a:t>Getting the reports for your site</a:t>
+              <a:t>Dormant analysers — found, left out, listed</a:t>
             </a:r>
           </a:p>
         </p:txBody>
@@ -5498,16 +6001,14 @@
         </p:nvSpPr>
         <p:spPr>
           <a:xfrm>
-            <a:off x="548640" y="1280160"/>
-            <a:ext cx="5440680" cy="2057400"/>
+            <a:off x="9784080" y="384048"/>
+            <a:ext cx="1828800" cy="457200"/>
           </a:xfrm>
           <a:prstGeom prst="roundRect">
-            <a:avLst>
-              <a:gd name="adj" fmla="val 8000"/>
-            </a:avLst>
-          </a:prstGeom>
-          <a:solidFill>
-            <a:srgbClr val="E5F2F0"/>
+            <a:avLst/>
+          </a:prstGeom>
+          <a:solidFill>
+            <a:srgbClr val="01485C"/>
           </a:solidFill>
           <a:ln>
             <a:noFill/>
@@ -5532,19 +6033,56 @@
           <a:lstStyle/>
           <a:p>
             <a:pPr algn="ctr"/>
-          </a:p>
-        </p:txBody>
-      </p:sp>
-      <p:sp>
-        <p:nvSpPr>
-          <p:cNvPr id="20" name="TextBox 19"/>
+            <a:r>
+              <a:rPr sz="1500" b="1">
+                <a:solidFill>
+                  <a:srgbClr val="FFFFFF"/>
+                </a:solidFill>
+              </a:rPr>
+              <a:t>i-STAT</a:t>
+            </a:r>
+          </a:p>
+        </p:txBody>
+      </p:sp>
+      <p:pic>
+        <p:nvPicPr>
+          <p:cNvPr id="20" name="Picture 19" descr="dormant_p1.png"/>
+          <p:cNvPicPr>
+            <a:picLocks noChangeAspect="1"/>
+          </p:cNvPicPr>
+          <p:nvPr/>
+        </p:nvPicPr>
+        <p:blipFill>
+          <a:blip r:embed="rId2"/>
+          <a:stretch>
+            <a:fillRect/>
+          </a:stretch>
+        </p:blipFill>
+        <p:spPr>
+          <a:xfrm>
+            <a:off x="548640" y="1143000"/>
+            <a:ext cx="3429521" cy="4846320"/>
+          </a:xfrm>
+          <a:prstGeom prst="rect">
+            <a:avLst/>
+          </a:prstGeom>
+          <a:ln>
+            <a:solidFill>
+              <a:srgbClr val="E2E8EA"/>
+            </a:solidFill>
+          </a:ln>
+        </p:spPr>
+      </p:pic>
+      <p:sp>
+        <p:nvSpPr>
+          <p:cNvPr id="21" name="TextBox 20"/>
           <p:cNvSpPr txBox="1"/>
           <p:nvPr/>
         </p:nvSpPr>
         <p:spPr>
           <a:xfrm>
-            <a:off x="777240" y="1417319"/>
-            <a:ext cx="4983480" cy="457200"/>
+            <a:off x="548640" y="6035040"/>
+            <a:ext cx="3429521" cy="365760"/>
           </a:xfrm>
           <a:prstGeom prst="rect">
             <a:avLst/>
@@ -5557,32 +6095,32 @@
           </a:bodyPr>
           <a:lstStyle/>
           <a:p>
-            <a:pPr algn="l">
-              <a:spcAft>
-                <a:spcPts val="600"/>
-              </a:spcAft>
-            </a:pPr>
-            <a:r>
-              <a:rPr sz="1500" b="1">
-                <a:solidFill>
-                  <a:srgbClr val="01485C"/>
-                </a:solidFill>
-              </a:rPr>
-              <a:t>1.  Ask the PoC team</a:t>
-            </a:r>
-          </a:p>
-        </p:txBody>
-      </p:sp>
-      <p:sp>
-        <p:nvSpPr>
-          <p:cNvPr id="21" name="TextBox 20"/>
+            <a:pPr algn="ctr">
+              <a:spcAft>
+                <a:spcPts val="600"/>
+              </a:spcAft>
+            </a:pPr>
+            <a:r>
+              <a:rPr sz="1100" b="0">
+                <a:solidFill>
+                  <a:srgbClr val="5F7178"/>
+                </a:solidFill>
+              </a:rPr>
+              <a:t>The dormant-analyser list for August 2026</a:t>
+            </a:r>
+          </a:p>
+        </p:txBody>
+      </p:sp>
+      <p:sp>
+        <p:nvSpPr>
+          <p:cNvPr id="22" name="TextBox 21"/>
           <p:cNvSpPr txBox="1"/>
           <p:nvPr/>
         </p:nvSpPr>
         <p:spPr>
           <a:xfrm>
-            <a:off x="777240" y="1847088"/>
-            <a:ext cx="4983480" cy="1417320"/>
+            <a:off x="4480560" y="1188720"/>
+            <a:ext cx="7132320" cy="4846320"/>
           </a:xfrm>
           <a:prstGeom prst="rect">
             <a:avLst/>
@@ -5601,26 +6139,319 @@
               </a:spcAft>
             </a:pPr>
             <a:r>
+              <a:rPr sz="1500" b="1">
+                <a:solidFill>
+                  <a:srgbClr val="01485C"/>
+                </a:solidFill>
+              </a:rPr>
+              <a:t>The four-month rule</a:t>
+            </a:r>
+          </a:p>
+          <a:p>
+            <a:pPr algn="l">
+              <a:spcAft>
+                <a:spcPts val="600"/>
+              </a:spcAft>
+            </a:pPr>
+            <a:r>
               <a:rPr sz="1200" b="0">
                 <a:solidFill>
                   <a:srgbClr val="17272E"/>
                 </a:solidFill>
               </a:rPr>
-              <a:t>Reports are generated centrally each month from the middleware exports and distributed by HHS folder.</a:t>
-            </a:r>
-          </a:p>
-        </p:txBody>
-      </p:sp>
-      <p:sp>
-        <p:nvSpPr>
-          <p:cNvPr id="22" name="Rounded Rectangle 21"/>
-          <p:cNvSpPr/>
-          <p:nvPr/>
-        </p:nvSpPr>
-        <p:spPr>
-          <a:xfrm>
-            <a:off x="6172200" y="1280160"/>
-            <a:ext cx="5440680" cy="2057400"/>
+              <a:t>An analyser with no cartridges, no simulator runs and no ceramic cleaning for four consecutive months is dormant: it gets no report and no longer counts against its site’s checks.</a:t>
+            </a:r>
+          </a:p>
+          <a:p>
+            <a:pPr algn="l">
+              <a:spcAft>
+                <a:spcPts val="600"/>
+              </a:spcAft>
+            </a:pPr>
+            <a:r>
+              <a:rPr sz="1200" b="0">
+                <a:solidFill>
+                  <a:srgbClr val="17272E"/>
+                </a:solidFill>
+              </a:rPr>
+              <a:t>One or two quiet months change nothing. The reports exist to catch wards skipping simulators, so nothing is removed early.</a:t>
+            </a:r>
+          </a:p>
+          <a:p>
+            <a:pPr algn="l">
+              <a:spcAft>
+                <a:spcPts val="600"/>
+              </a:spcAft>
+            </a:pPr>
+            <a:r>
+              <a:rPr sz="1200" b="0">
+                <a:solidFill>
+                  <a:srgbClr val="17272E"/>
+                </a:solidFill>
+              </a:rPr>
+              <a:t>Any use brings the unit straight back the next month.</a:t>
+            </a:r>
+          </a:p>
+          <a:p>
+            <a:pPr algn="l">
+              <a:spcAft>
+                <a:spcPts val="600"/>
+              </a:spcAft>
+            </a:pPr>
+            <a:r>
+              <a:rPr sz="1200" b="0">
+                <a:solidFill>
+                  <a:srgbClr val="17272E"/>
+                </a:solidFill>
+              </a:rPr>
+              <a:t>Every run writes the list: hospital, location, serial, months idle and last activity. In August 2026, 163 units — mostly old models sitting beside their replacements — a ready-made retirement list.</a:t>
+            </a:r>
+          </a:p>
+        </p:txBody>
+      </p:sp>
+      <p:sp>
+        <p:nvSpPr>
+          <p:cNvPr id="23" name="TextBox 22"/>
+          <p:cNvSpPr txBox="1"/>
+          <p:nvPr/>
+        </p:nvSpPr>
+        <p:spPr>
+          <a:xfrm>
+            <a:off x="548640" y="6263640"/>
+            <a:ext cx="11064240" cy="365760"/>
+          </a:xfrm>
+          <a:prstGeom prst="rect">
+            <a:avLst/>
+          </a:prstGeom>
+          <a:noFill/>
+        </p:spPr>
+        <p:txBody>
+          <a:bodyPr wrap="square">
+            <a:spAutoFit/>
+          </a:bodyPr>
+          <a:lstStyle/>
+          <a:p>
+            <a:pPr algn="l">
+              <a:spcAft>
+                <a:spcPts val="600"/>
+              </a:spcAft>
+            </a:pPr>
+            <a:r>
+              <a:rPr sz="1100" b="0">
+                <a:solidFill>
+                  <a:srgbClr val="5F7178"/>
+                </a:solidFill>
+              </a:rPr>
+              <a:t>Conceived, designed and built by Craig MacKenzie · Chemistry Department, Townsville Group Laboratory · Pathology Queensland</a:t>
+            </a:r>
+          </a:p>
+        </p:txBody>
+      </p:sp>
+    </p:spTree>
+  </p:cSld>
+  <p:clrMapOvr>
+    <a:masterClrMapping/>
+  </p:clrMapOvr>
+</p:sld>
+</file>
+
+<file path=ppt/slides/slide9.xml><?xml version="1.0" encoding="utf-8"?>
+<p:sld xmlns:a="http://schemas.openxmlformats.org/drawingml/2006/main" xmlns:p="http://schemas.openxmlformats.org/presentationml/2006/main" xmlns:r="http://schemas.openxmlformats.org/officeDocument/2006/relationships">
+  <p:cSld>
+    <p:spTree>
+      <p:nvGrpSpPr>
+        <p:cNvPr id="1" name=""/>
+        <p:cNvGrpSpPr/>
+        <p:nvPr/>
+      </p:nvGrpSpPr>
+      <p:grpSpPr/>
+      <p:sp>
+        <p:nvSpPr>
+          <p:cNvPr id="12" name="Shape 7"/>
+          <p:cNvSpPr/>
+          <p:nvPr/>
+        </p:nvSpPr>
+        <p:spPr>
+          <a:xfrm>
+            <a:off x="0" y="6793992"/>
+            <a:ext cx="2040636" cy="64008"/>
+          </a:xfrm>
+          <a:prstGeom prst="rect">
+            <a:avLst/>
+          </a:prstGeom>
+          <a:solidFill>
+            <a:srgbClr val="01485C"/>
+          </a:solidFill>
+          <a:ln/>
+        </p:spPr>
+        <p:txBody>
+          <a:bodyPr/>
+          <a:p/>
+        </p:txBody>
+      </p:sp>
+      <p:sp>
+        <p:nvSpPr>
+          <p:cNvPr id="13" name="Shape 8"/>
+          <p:cNvSpPr/>
+          <p:nvPr/>
+        </p:nvSpPr>
+        <p:spPr>
+          <a:xfrm>
+            <a:off x="2031492" y="6793992"/>
+            <a:ext cx="2040636" cy="64008"/>
+          </a:xfrm>
+          <a:prstGeom prst="rect">
+            <a:avLst/>
+          </a:prstGeom>
+          <a:solidFill>
+            <a:srgbClr val="146175"/>
+          </a:solidFill>
+          <a:ln/>
+        </p:spPr>
+        <p:txBody>
+          <a:bodyPr/>
+          <a:p/>
+        </p:txBody>
+      </p:sp>
+      <p:sp>
+        <p:nvSpPr>
+          <p:cNvPr id="14" name="Shape 9"/>
+          <p:cNvSpPr/>
+          <p:nvPr/>
+        </p:nvSpPr>
+        <p:spPr>
+          <a:xfrm>
+            <a:off x="4062984" y="6793992"/>
+            <a:ext cx="2040636" cy="64008"/>
+          </a:xfrm>
+          <a:prstGeom prst="rect">
+            <a:avLst/>
+          </a:prstGeom>
+          <a:solidFill>
+            <a:srgbClr val="11B5AE"/>
+          </a:solidFill>
+          <a:ln/>
+        </p:spPr>
+        <p:txBody>
+          <a:bodyPr/>
+          <a:p/>
+        </p:txBody>
+      </p:sp>
+      <p:sp>
+        <p:nvSpPr>
+          <p:cNvPr id="15" name="Shape 10"/>
+          <p:cNvSpPr/>
+          <p:nvPr/>
+        </p:nvSpPr>
+        <p:spPr>
+          <a:xfrm>
+            <a:off x="6094476" y="6793992"/>
+            <a:ext cx="2040636" cy="64008"/>
+          </a:xfrm>
+          <a:prstGeom prst="rect">
+            <a:avLst/>
+          </a:prstGeom>
+          <a:solidFill>
+            <a:srgbClr val="6CCAD4"/>
+          </a:solidFill>
+          <a:ln/>
+        </p:spPr>
+        <p:txBody>
+          <a:bodyPr/>
+          <a:p/>
+        </p:txBody>
+      </p:sp>
+      <p:sp>
+        <p:nvSpPr>
+          <p:cNvPr id="16" name="Shape 11"/>
+          <p:cNvSpPr/>
+          <p:nvPr/>
+        </p:nvSpPr>
+        <p:spPr>
+          <a:xfrm>
+            <a:off x="8125968" y="6793992"/>
+            <a:ext cx="2040636" cy="64008"/>
+          </a:xfrm>
+          <a:prstGeom prst="rect">
+            <a:avLst/>
+          </a:prstGeom>
+          <a:solidFill>
+            <a:srgbClr val="7FC04C"/>
+          </a:solidFill>
+          <a:ln/>
+        </p:spPr>
+        <p:txBody>
+          <a:bodyPr/>
+          <a:p/>
+        </p:txBody>
+      </p:sp>
+      <p:sp>
+        <p:nvSpPr>
+          <p:cNvPr id="17" name="Shape 12"/>
+          <p:cNvSpPr/>
+          <p:nvPr/>
+        </p:nvSpPr>
+        <p:spPr>
+          <a:xfrm>
+            <a:off x="10157460" y="6793992"/>
+            <a:ext cx="2040636" cy="64008"/>
+          </a:xfrm>
+          <a:prstGeom prst="rect">
+            <a:avLst/>
+          </a:prstGeom>
+          <a:solidFill>
+            <a:srgbClr val="E1DD57"/>
+          </a:solidFill>
+          <a:ln/>
+        </p:spPr>
+        <p:txBody>
+          <a:bodyPr/>
+          <a:p/>
+        </p:txBody>
+      </p:sp>
+      <p:sp>
+        <p:nvSpPr>
+          <p:cNvPr id="18" name="TextBox 17"/>
+          <p:cNvSpPr txBox="1"/>
+          <p:nvPr/>
+        </p:nvSpPr>
+        <p:spPr>
+          <a:xfrm>
+            <a:off x="548640" y="320040"/>
+            <a:ext cx="11064240" cy="685800"/>
+          </a:xfrm>
+          <a:prstGeom prst="rect">
+            <a:avLst/>
+          </a:prstGeom>
+          <a:noFill/>
+        </p:spPr>
+        <p:txBody>
+          <a:bodyPr wrap="none">
+            <a:spAutoFit/>
+          </a:bodyPr>
+          <a:lstStyle/>
+          <a:p>
+            <a:r>
+              <a:rPr sz="3000" b="1">
+                <a:solidFill>
+                  <a:srgbClr val="01485C"/>
+                </a:solidFill>
+              </a:rPr>
+              <a:t>How it protects the data</a:t>
+            </a:r>
+          </a:p>
+        </p:txBody>
+      </p:sp>
+      <p:sp>
+        <p:nvSpPr>
+          <p:cNvPr id="19" name="Rounded Rectangle 18"/>
+          <p:cNvSpPr/>
+          <p:nvPr/>
+        </p:nvSpPr>
+        <p:spPr>
+          <a:xfrm>
+            <a:off x="548640" y="1280160"/>
+            <a:ext cx="5440680" cy="2103120"/>
           </a:xfrm>
           <a:prstGeom prst="roundRect">
             <a:avLst>
@@ -5658,13 +6489,13 @@
       </p:sp>
       <p:sp>
         <p:nvSpPr>
-          <p:cNvPr id="23" name="TextBox 22"/>
+          <p:cNvPr id="20" name="TextBox 19"/>
           <p:cNvSpPr txBox="1"/>
           <p:nvPr/>
         </p:nvSpPr>
         <p:spPr>
           <a:xfrm>
-            <a:off x="6400800" y="1417319"/>
+            <a:off x="777240" y="1417319"/>
             <a:ext cx="4983480" cy="457200"/>
           </a:xfrm>
           <a:prstGeom prst="rect">
@@ -5689,21 +6520,21 @@
                   <a:srgbClr val="01485C"/>
                 </a:solidFill>
               </a:rPr>
-              <a:t>2.  Tell us your wards</a:t>
-            </a:r>
-          </a:p>
-        </p:txBody>
-      </p:sp>
-      <p:sp>
-        <p:nvSpPr>
-          <p:cNvPr id="24" name="TextBox 23"/>
+              <a:t>Runs from an encrypted USB drive</a:t>
+            </a:r>
+          </a:p>
+        </p:txBody>
+      </p:sp>
+      <p:sp>
+        <p:nvSpPr>
+          <p:cNvPr id="21" name="TextBox 20"/>
           <p:cNvSpPr txBox="1"/>
           <p:nvPr/>
         </p:nvSpPr>
         <p:spPr>
           <a:xfrm>
-            <a:off x="6400800" y="1847088"/>
-            <a:ext cx="4983480" cy="1417320"/>
+            <a:off x="777240" y="1847088"/>
+            <a:ext cx="4983480" cy="1463039"/>
           </a:xfrm>
           <a:prstGeom prst="rect">
             <a:avLst/>
@@ -5727,21 +6558,21 @@
                   <a:srgbClr val="17272E"/>
                 </a:solidFill>
               </a:rPr>
-              <a:t>Large sites get one report per ward. If a ward name or split is wrong, it is a one-line change.</a:t>
-            </a:r>
-          </a:p>
-        </p:txBody>
-      </p:sp>
-      <p:sp>
-        <p:nvSpPr>
-          <p:cNvPr id="25" name="Rounded Rectangle 24"/>
-          <p:cNvSpPr/>
-          <p:nvPr/>
-        </p:nvSpPr>
-        <p:spPr>
-          <a:xfrm>
-            <a:off x="548640" y="3520440"/>
-            <a:ext cx="5440680" cy="2057400"/>
+              <a:t>Its own Python runtime, no installation, no admin rights, no changes to the PC. BitLocker To Go encrypts the whole drive.</a:t>
+            </a:r>
+          </a:p>
+        </p:txBody>
+      </p:sp>
+      <p:sp>
+        <p:nvSpPr>
+          <p:cNvPr id="22" name="Rounded Rectangle 21"/>
+          <p:cNvSpPr/>
+          <p:nvPr/>
+        </p:nvSpPr>
+        <p:spPr>
+          <a:xfrm>
+            <a:off x="6172200" y="1280160"/>
+            <a:ext cx="5440680" cy="2103120"/>
           </a:xfrm>
           <a:prstGeom prst="roundRect">
             <a:avLst>
@@ -5779,13 +6610,13 @@
       </p:sp>
       <p:sp>
         <p:nvSpPr>
-          <p:cNvPr id="26" name="TextBox 25"/>
+          <p:cNvPr id="23" name="TextBox 22"/>
           <p:cNvSpPr txBox="1"/>
           <p:nvPr/>
         </p:nvSpPr>
         <p:spPr>
           <a:xfrm>
-            <a:off x="777240" y="3657600"/>
+            <a:off x="6400800" y="1417319"/>
             <a:ext cx="4983480" cy="457200"/>
           </a:xfrm>
           <a:prstGeom prst="rect">
@@ -5810,21 +6641,21 @@
                   <a:srgbClr val="01485C"/>
                 </a:solidFill>
               </a:rPr>
-              <a:t>3.  Check the dormant list</a:t>
-            </a:r>
-          </a:p>
-        </p:txBody>
-      </p:sp>
-      <p:sp>
-        <p:nvSpPr>
-          <p:cNvPr id="27" name="TextBox 26"/>
+              <a:t>Offline by enforcement</a:t>
+            </a:r>
+          </a:p>
+        </p:txBody>
+      </p:sp>
+      <p:sp>
+        <p:nvSpPr>
+          <p:cNvPr id="24" name="TextBox 23"/>
           <p:cNvSpPr txBox="1"/>
           <p:nvPr/>
         </p:nvSpPr>
         <p:spPr>
           <a:xfrm>
-            <a:off x="777240" y="4087368"/>
-            <a:ext cx="4983480" cy="1417320"/>
+            <a:off x="6400800" y="1847088"/>
+            <a:ext cx="4983480" cy="1463039"/>
           </a:xfrm>
           <a:prstGeom prst="rect">
             <a:avLst/>
@@ -5848,21 +6679,21 @@
                   <a:srgbClr val="17272E"/>
                 </a:solidFill>
               </a:rPr>
-              <a:t>Units on it are candidates for retirement, or should be back in service and maintained.</a:t>
-            </a:r>
-          </a:p>
-        </p:txBody>
-      </p:sp>
-      <p:sp>
-        <p:nvSpPr>
-          <p:cNvPr id="28" name="Rounded Rectangle 27"/>
-          <p:cNvSpPr/>
-          <p:nvPr/>
-        </p:nvSpPr>
-        <p:spPr>
-          <a:xfrm>
-            <a:off x="6172200" y="3520440"/>
-            <a:ext cx="5440680" cy="2057400"/>
+              <a:t>All three servers bind to the local machine only, and a runtime guard blocks and logs any attempt to reach the network. Zero outbound connections, ever.</a:t>
+            </a:r>
+          </a:p>
+        </p:txBody>
+      </p:sp>
+      <p:sp>
+        <p:nvSpPr>
+          <p:cNvPr id="25" name="Rounded Rectangle 24"/>
+          <p:cNvSpPr/>
+          <p:nvPr/>
+        </p:nvSpPr>
+        <p:spPr>
+          <a:xfrm>
+            <a:off x="548640" y="3566160"/>
+            <a:ext cx="5440680" cy="2103120"/>
           </a:xfrm>
           <a:prstGeom prst="roundRect">
             <a:avLst>
@@ -5870,7 +6701,7 @@
             </a:avLst>
           </a:prstGeom>
           <a:solidFill>
-            <a:srgbClr val="E5F2F0"/>
+            <a:srgbClr val="FDF0E4"/>
           </a:solidFill>
           <a:ln>
             <a:noFill/>
@@ -5900,13 +6731,13 @@
       </p:sp>
       <p:sp>
         <p:nvSpPr>
-          <p:cNvPr id="29" name="TextBox 28"/>
+          <p:cNvPr id="26" name="TextBox 25"/>
           <p:cNvSpPr txBox="1"/>
           <p:nvPr/>
         </p:nvSpPr>
         <p:spPr>
           <a:xfrm>
-            <a:off x="6400800" y="3657600"/>
+            <a:off x="777240" y="3703320"/>
             <a:ext cx="4983480" cy="457200"/>
           </a:xfrm>
           <a:prstGeom prst="rect">
@@ -5928,24 +6759,24 @@
             <a:r>
               <a:rPr sz="1500" b="1">
                 <a:solidFill>
-                  <a:srgbClr val="01485C"/>
-                </a:solidFill>
-              </a:rPr>
-              <a:t>4.  Read the summaries first</a:t>
-            </a:r>
-          </a:p>
-        </p:txBody>
-      </p:sp>
-      <p:sp>
-        <p:nvSpPr>
-          <p:cNvPr id="30" name="TextBox 29"/>
+                  <a:srgbClr val="B4540A"/>
+                </a:solidFill>
+              </a:rPr>
+              <a:t>Named staff data encrypted</a:t>
+            </a:r>
+          </a:p>
+        </p:txBody>
+      </p:sp>
+      <p:sp>
+        <p:nvSpPr>
+          <p:cNvPr id="27" name="TextBox 26"/>
           <p:cNvSpPr txBox="1"/>
           <p:nvPr/>
         </p:nvSpPr>
         <p:spPr>
           <a:xfrm>
-            <a:off x="6400800" y="4087368"/>
-            <a:ext cx="4983480" cy="1417320"/>
+            <a:off x="777240" y="4133087"/>
+            <a:ext cx="4983480" cy="1463039"/>
           </a:xfrm>
           <a:prstGeom prst="rect">
             <a:avLst/>
@@ -5969,21 +6800,66 @@
                   <a:srgbClr val="17272E"/>
                 </a:solidFill>
               </a:rPr>
-              <a:t>Site Overview for a site lead, Area Summary for an area manager, then the ward reports that need action.</a:t>
-            </a:r>
-          </a:p>
-        </p:txBody>
-      </p:sp>
-      <p:sp>
-        <p:nvSpPr>
-          <p:cNvPr id="31" name="TextBox 30"/>
+              <a:t>The rolling staff and device history is AES-encrypted with a password that is never stored. Reports cannot be generated until it is unlocked.</a:t>
+            </a:r>
+          </a:p>
+        </p:txBody>
+      </p:sp>
+      <p:sp>
+        <p:nvSpPr>
+          <p:cNvPr id="28" name="Rounded Rectangle 27"/>
+          <p:cNvSpPr/>
+          <p:nvPr/>
+        </p:nvSpPr>
+        <p:spPr>
+          <a:xfrm>
+            <a:off x="6172200" y="3566160"/>
+            <a:ext cx="5440680" cy="2103120"/>
+          </a:xfrm>
+          <a:prstGeom prst="roundRect">
+            <a:avLst>
+              <a:gd name="adj" fmla="val 8000"/>
+            </a:avLst>
+          </a:prstGeom>
+          <a:solidFill>
+            <a:srgbClr val="E5F2F0"/>
+          </a:solidFill>
+          <a:ln>
+            <a:noFill/>
+          </a:ln>
+        </p:spPr>
+        <p:style>
+          <a:lnRef idx="1">
+            <a:schemeClr val="accent1"/>
+          </a:lnRef>
+          <a:fillRef idx="3">
+            <a:schemeClr val="accent1"/>
+          </a:fillRef>
+          <a:effectRef idx="2">
+            <a:schemeClr val="accent1"/>
+          </a:effectRef>
+          <a:fontRef idx="minor">
+            <a:schemeClr val="lt1"/>
+          </a:fontRef>
+        </p:style>
+        <p:txBody>
+          <a:bodyPr rtlCol="0" anchor="ctr"/>
+          <a:lstStyle/>
+          <a:p>
+            <a:pPr algn="ctr"/>
+          </a:p>
+        </p:txBody>
+      </p:sp>
+      <p:sp>
+        <p:nvSpPr>
+          <p:cNvPr id="29" name="TextBox 28"/>
           <p:cNvSpPr txBox="1"/>
           <p:nvPr/>
         </p:nvSpPr>
         <p:spPr>
           <a:xfrm>
-            <a:off x="548640" y="5806440"/>
-            <a:ext cx="11064240" cy="411480"/>
+            <a:off x="6400800" y="3703320"/>
+            <a:ext cx="4983480" cy="457200"/>
           </a:xfrm>
           <a:prstGeom prst="rect">
             <a:avLst/>
@@ -6002,12 +6878,88 @@
               </a:spcAft>
             </a:pPr>
             <a:r>
+              <a:rPr sz="1500" b="1">
+                <a:solidFill>
+                  <a:srgbClr val="01485C"/>
+                </a:solidFill>
+              </a:rPr>
+              <a:t>Controlled roll-out</a:t>
+            </a:r>
+          </a:p>
+        </p:txBody>
+      </p:sp>
+      <p:sp>
+        <p:nvSpPr>
+          <p:cNvPr id="30" name="TextBox 29"/>
+          <p:cNvSpPr txBox="1"/>
+          <p:nvPr/>
+        </p:nvSpPr>
+        <p:spPr>
+          <a:xfrm>
+            <a:off x="6400800" y="4133087"/>
+            <a:ext cx="4983480" cy="1463039"/>
+          </a:xfrm>
+          <a:prstGeom prst="rect">
+            <a:avLst/>
+          </a:prstGeom>
+          <a:noFill/>
+        </p:spPr>
+        <p:txBody>
+          <a:bodyPr wrap="square">
+            <a:spAutoFit/>
+          </a:bodyPr>
+          <a:lstStyle/>
+          <a:p>
+            <a:pPr algn="l">
+              <a:spcAft>
+                <a:spcPts val="600"/>
+              </a:spcAft>
+            </a:pPr>
+            <a:r>
+              <a:rPr sz="1200" b="0">
+                <a:solidFill>
+                  <a:srgbClr val="17272E"/>
+                </a:solidFill>
+              </a:rPr>
+              <a:t>It runs only on PCs approved by the PoC lead, reviewed on the 12-month QIS cycle, with an audit trail of every launch and every report generated.</a:t>
+            </a:r>
+          </a:p>
+        </p:txBody>
+      </p:sp>
+      <p:sp>
+        <p:nvSpPr>
+          <p:cNvPr id="31" name="TextBox 30"/>
+          <p:cNvSpPr txBox="1"/>
+          <p:nvPr/>
+        </p:nvSpPr>
+        <p:spPr>
+          <a:xfrm>
+            <a:off x="548640" y="5806440"/>
+            <a:ext cx="11064240" cy="411480"/>
+          </a:xfrm>
+          <a:prstGeom prst="rect">
+            <a:avLst/>
+          </a:prstGeom>
+          <a:noFill/>
+        </p:spPr>
+        <p:txBody>
+          <a:bodyPr wrap="square">
+            <a:spAutoFit/>
+          </a:bodyPr>
+          <a:lstStyle/>
+          <a:p>
+            <a:pPr algn="l">
+              <a:spcAft>
+                <a:spcPts val="600"/>
+              </a:spcAft>
+            </a:pPr>
+            <a:r>
               <a:rPr sz="1100" b="0">
                 <a:solidFill>
                   <a:srgbClr val="5F7178"/>
                 </a:solidFill>
               </a:rPr>
-              <a:t>Support: Pathology Queensland Point of Care team · Chemistry Department, Townsville Group Laboratory</a:t>
+              <a:t>Full detail for IT: SECURITY_README.md on the drive and the Security Briefing deck.</a:t>
             </a:r>
           </a:p>
         </p:txBody>

</xml_diff>

<commit_message>
Manager deck and landing page: ABL department report walkthrough and hospital summary
Four ABL slides (Townsville ED pages 1-5 explained, hospital summary) and two
ABL gallery entries, from a synthetic export with de-identified operators.

Co-Authored-By: Claude Fable 5.1 <noreply@anthropic.com>
</commit_message>
<xml_diff>
--- a/PQ_Report_Generator_Overview_for_Managers.pptx
+++ b/PQ_Report_Generator_Overview_for_Managers.pptx
@@ -15,6 +15,10 @@
     <p:sldId id="263" r:id="rId14"/>
     <p:sldId id="264" r:id="rId15"/>
     <p:sldId id="265" r:id="rId16"/>
+    <p:sldId id="266" r:id="rId17"/>
+    <p:sldId id="267" r:id="rId18"/>
+    <p:sldId id="268" r:id="rId7"/>
+    <p:sldId id="269" r:id="rId6"/>
   </p:sldIdLst>
   <p:notesMasterIdLst>
     <p:notesMasterId r:id="rId19"/>
@@ -1549,6 +1553,2160 @@
                   <a:srgbClr val="01485C"/>
                 </a:solidFill>
               </a:rPr>
+              <a:t>ABL — the Hospital Summary, August 2026</a:t>
+            </a:r>
+          </a:p>
+        </p:txBody>
+      </p:sp>
+      <p:sp>
+        <p:nvSpPr>
+          <p:cNvPr id="19" name="Rounded Rectangle 18"/>
+          <p:cNvSpPr/>
+          <p:nvPr/>
+        </p:nvSpPr>
+        <p:spPr>
+          <a:xfrm>
+            <a:off x="9784080" y="384048"/>
+            <a:ext cx="1828800" cy="457200"/>
+          </a:xfrm>
+          <a:prstGeom prst="roundRect">
+            <a:avLst/>
+          </a:prstGeom>
+          <a:solidFill>
+            <a:srgbClr val="01485C"/>
+          </a:solidFill>
+          <a:ln>
+            <a:noFill/>
+          </a:ln>
+        </p:spPr>
+        <p:style>
+          <a:lnRef idx="1">
+            <a:schemeClr val="accent1"/>
+          </a:lnRef>
+          <a:fillRef idx="3">
+            <a:schemeClr val="accent1"/>
+          </a:fillRef>
+          <a:effectRef idx="2">
+            <a:schemeClr val="accent1"/>
+          </a:effectRef>
+          <a:fontRef idx="minor">
+            <a:schemeClr val="lt1"/>
+          </a:fontRef>
+        </p:style>
+        <p:txBody>
+          <a:bodyPr rtlCol="0" anchor="ctr"/>
+          <a:lstStyle/>
+          <a:p>
+            <a:pPr algn="ctr"/>
+            <a:r>
+              <a:rPr sz="1500" b="1">
+                <a:solidFill>
+                  <a:srgbClr val="FFFFFF"/>
+                </a:solidFill>
+              </a:rPr>
+              <a:t>i-STAT</a:t>
+            </a:r>
+          </a:p>
+        </p:txBody>
+      </p:sp>
+      <p:pic>
+        <p:nvPicPr>
+          <p:cNvPr id="20" name="Picture 19" descr="abl_hosp_p1.png"/>
+          <p:cNvPicPr>
+            <a:picLocks noChangeAspect="1"/>
+          </p:cNvPicPr>
+          <p:nvPr/>
+        </p:nvPicPr>
+        <p:blipFill>
+          <a:blip r:embed="rId2"/>
+          <a:stretch>
+            <a:fillRect/>
+          </a:stretch>
+        </p:blipFill>
+        <p:spPr>
+          <a:xfrm>
+            <a:off x="548640" y="1143000"/>
+            <a:ext cx="3429521" cy="4846320"/>
+          </a:xfrm>
+          <a:prstGeom prst="rect">
+            <a:avLst/>
+          </a:prstGeom>
+          <a:ln>
+            <a:solidFill>
+              <a:srgbClr val="E2E8EA"/>
+            </a:solidFill>
+          </a:ln>
+        </p:spPr>
+      </p:pic>
+      <p:sp>
+        <p:nvSpPr>
+          <p:cNvPr id="21" name="TextBox 20"/>
+          <p:cNvSpPr txBox="1"/>
+          <p:nvPr/>
+        </p:nvSpPr>
+        <p:spPr>
+          <a:xfrm>
+            <a:off x="548640" y="6035040"/>
+            <a:ext cx="3429521" cy="365760"/>
+          </a:xfrm>
+          <a:prstGeom prst="rect">
+            <a:avLst/>
+          </a:prstGeom>
+          <a:noFill/>
+        </p:spPr>
+        <p:txBody>
+          <a:bodyPr wrap="square">
+            <a:spAutoFit/>
+          </a:bodyPr>
+          <a:lstStyle/>
+          <a:p>
+            <a:pPr algn="ctr">
+              <a:spcAft>
+                <a:spcPts val="600"/>
+              </a:spcAft>
+            </a:pPr>
+            <a:r>
+              <a:rPr sz="1100" b="0">
+                <a:solidFill>
+                  <a:srgbClr val="5F7178"/>
+                </a:solidFill>
+              </a:rPr>
+              <a:t>One page per hospital, every department and analyser</a:t>
+            </a:r>
+          </a:p>
+        </p:txBody>
+      </p:sp>
+      <p:sp>
+        <p:nvSpPr>
+          <p:cNvPr id="22" name="TextBox 21"/>
+          <p:cNvSpPr txBox="1"/>
+          <p:nvPr/>
+        </p:nvSpPr>
+        <p:spPr>
+          <a:xfrm>
+            <a:off x="4298201" y="1188720"/>
+            <a:ext cx="7314678" cy="4846320"/>
+          </a:xfrm>
+          <a:prstGeom prst="rect">
+            <a:avLst/>
+          </a:prstGeom>
+          <a:noFill/>
+        </p:spPr>
+        <p:txBody>
+          <a:bodyPr wrap="square">
+            <a:spAutoFit/>
+          </a:bodyPr>
+          <a:lstStyle/>
+          <a:p>
+            <a:pPr algn="l">
+              <a:spcAft>
+                <a:spcPts val="600"/>
+              </a:spcAft>
+            </a:pPr>
+            <a:r>
+              <a:rPr sz="1500" b="1">
+                <a:solidFill>
+                  <a:srgbClr val="01485C"/>
+                </a:solidFill>
+              </a:rPr>
+              <a:t>The whole hospital on one page</a:t>
+            </a:r>
+          </a:p>
+          <a:p>
+            <a:pPr algn="l">
+              <a:spcAft>
+                <a:spcPts val="600"/>
+              </a:spcAft>
+            </a:pPr>
+            <a:r>
+              <a:rPr sz="1200" b="0">
+                <a:solidFill>
+                  <a:srgbClr val="17272E"/>
+                </a:solidFill>
+              </a:rPr>
+              <a:t>Hospital Snapshot: the hospital’s error rate and band, its departments, how many operators are flagged and in which departments, low-volume operators, and any analyser with recent history that did not report this month.</a:t>
+            </a:r>
+          </a:p>
+          <a:p>
+            <a:pPr algn="l">
+              <a:spcAft>
+                <a:spcPts val="600"/>
+              </a:spcAft>
+            </a:pPr>
+            <a:r>
+              <a:rPr sz="1200" b="0">
+                <a:solidFill>
+                  <a:srgbClr val="17272E"/>
+                </a:solidFill>
+              </a:rPr>
+              <a:t>Departments table: analysers, operators, tests, errors, error % and band, flagged and low-volume counts per department, with a whole-hospital total.</a:t>
+            </a:r>
+          </a:p>
+          <a:p>
+            <a:pPr algn="l">
+              <a:spcAft>
+                <a:spcPts val="600"/>
+              </a:spcAft>
+            </a:pPr>
+            <a:r>
+              <a:rPr sz="1200" b="0">
+                <a:solidFill>
+                  <a:srgbClr val="17272E"/>
+                </a:solidFill>
+              </a:rPr>
+              <a:t>Analysers table: every analyser with its tests, errors, error % and band; an analyser that has gone quiet appears in red with its last active month.</a:t>
+            </a:r>
+          </a:p>
+          <a:p>
+            <a:pPr algn="l">
+              <a:spcAft>
+                <a:spcPts val="600"/>
+              </a:spcAft>
+            </a:pPr>
+            <a:r>
+              <a:rPr sz="1200" b="0">
+                <a:solidFill>
+                  <a:srgbClr val="17272E"/>
+                </a:solidFill>
+              </a:rPr>
+              <a:t>Names stay in the department reports; the summary is for the site lead.</a:t>
+            </a:r>
+          </a:p>
+        </p:txBody>
+      </p:sp>
+      <p:sp>
+        <p:nvSpPr>
+          <p:cNvPr id="23" name="TextBox 22"/>
+          <p:cNvSpPr txBox="1"/>
+          <p:nvPr/>
+        </p:nvSpPr>
+        <p:spPr>
+          <a:xfrm>
+            <a:off x="548640" y="6263640"/>
+            <a:ext cx="11064240" cy="365760"/>
+          </a:xfrm>
+          <a:prstGeom prst="rect">
+            <a:avLst/>
+          </a:prstGeom>
+          <a:noFill/>
+        </p:spPr>
+        <p:txBody>
+          <a:bodyPr wrap="square">
+            <a:spAutoFit/>
+          </a:bodyPr>
+          <a:lstStyle/>
+          <a:p>
+            <a:pPr algn="l">
+              <a:spcAft>
+                <a:spcPts val="600"/>
+              </a:spcAft>
+            </a:pPr>
+            <a:r>
+              <a:rPr sz="1100" b="0">
+                <a:solidFill>
+                  <a:srgbClr val="5F7178"/>
+                </a:solidFill>
+              </a:rPr>
+              <a:t>Conceived, designed and built by Craig MacKenzie · Chemistry Department, Townsville Group Laboratory · Pathology Queensland</a:t>
+            </a:r>
+          </a:p>
+        </p:txBody>
+      </p:sp>
+    </p:spTree>
+  </p:cSld>
+  <p:clrMapOvr>
+    <a:masterClrMapping/>
+  </p:clrMapOvr>
+</p:sld>
+</file>
+
+<file path=ppt/slides/slide11.xml><?xml version="1.0" encoding="utf-8"?>
+<p:sld xmlns:a="http://schemas.openxmlformats.org/drawingml/2006/main" xmlns:p="http://schemas.openxmlformats.org/presentationml/2006/main" xmlns:r="http://schemas.openxmlformats.org/officeDocument/2006/relationships">
+  <p:cSld>
+    <p:spTree>
+      <p:nvGrpSpPr>
+        <p:cNvPr id="1" name=""/>
+        <p:cNvGrpSpPr/>
+        <p:nvPr/>
+      </p:nvGrpSpPr>
+      <p:grpSpPr/>
+      <p:sp>
+        <p:nvSpPr>
+          <p:cNvPr id="12" name="Shape 7"/>
+          <p:cNvSpPr/>
+          <p:nvPr/>
+        </p:nvSpPr>
+        <p:spPr>
+          <a:xfrm>
+            <a:off x="0" y="6793992"/>
+            <a:ext cx="2040636" cy="64008"/>
+          </a:xfrm>
+          <a:prstGeom prst="rect">
+            <a:avLst/>
+          </a:prstGeom>
+          <a:solidFill>
+            <a:srgbClr val="01485C"/>
+          </a:solidFill>
+          <a:ln/>
+        </p:spPr>
+        <p:txBody>
+          <a:bodyPr/>
+          <a:p/>
+        </p:txBody>
+      </p:sp>
+      <p:sp>
+        <p:nvSpPr>
+          <p:cNvPr id="13" name="Shape 8"/>
+          <p:cNvSpPr/>
+          <p:nvPr/>
+        </p:nvSpPr>
+        <p:spPr>
+          <a:xfrm>
+            <a:off x="2031492" y="6793992"/>
+            <a:ext cx="2040636" cy="64008"/>
+          </a:xfrm>
+          <a:prstGeom prst="rect">
+            <a:avLst/>
+          </a:prstGeom>
+          <a:solidFill>
+            <a:srgbClr val="146175"/>
+          </a:solidFill>
+          <a:ln/>
+        </p:spPr>
+        <p:txBody>
+          <a:bodyPr/>
+          <a:p/>
+        </p:txBody>
+      </p:sp>
+      <p:sp>
+        <p:nvSpPr>
+          <p:cNvPr id="14" name="Shape 9"/>
+          <p:cNvSpPr/>
+          <p:nvPr/>
+        </p:nvSpPr>
+        <p:spPr>
+          <a:xfrm>
+            <a:off x="4062984" y="6793992"/>
+            <a:ext cx="2040636" cy="64008"/>
+          </a:xfrm>
+          <a:prstGeom prst="rect">
+            <a:avLst/>
+          </a:prstGeom>
+          <a:solidFill>
+            <a:srgbClr val="11B5AE"/>
+          </a:solidFill>
+          <a:ln/>
+        </p:spPr>
+        <p:txBody>
+          <a:bodyPr/>
+          <a:p/>
+        </p:txBody>
+      </p:sp>
+      <p:sp>
+        <p:nvSpPr>
+          <p:cNvPr id="15" name="Shape 10"/>
+          <p:cNvSpPr/>
+          <p:nvPr/>
+        </p:nvSpPr>
+        <p:spPr>
+          <a:xfrm>
+            <a:off x="6094476" y="6793992"/>
+            <a:ext cx="2040636" cy="64008"/>
+          </a:xfrm>
+          <a:prstGeom prst="rect">
+            <a:avLst/>
+          </a:prstGeom>
+          <a:solidFill>
+            <a:srgbClr val="6CCAD4"/>
+          </a:solidFill>
+          <a:ln/>
+        </p:spPr>
+        <p:txBody>
+          <a:bodyPr/>
+          <a:p/>
+        </p:txBody>
+      </p:sp>
+      <p:sp>
+        <p:nvSpPr>
+          <p:cNvPr id="16" name="Shape 11"/>
+          <p:cNvSpPr/>
+          <p:nvPr/>
+        </p:nvSpPr>
+        <p:spPr>
+          <a:xfrm>
+            <a:off x="8125968" y="6793992"/>
+            <a:ext cx="2040636" cy="64008"/>
+          </a:xfrm>
+          <a:prstGeom prst="rect">
+            <a:avLst/>
+          </a:prstGeom>
+          <a:solidFill>
+            <a:srgbClr val="7FC04C"/>
+          </a:solidFill>
+          <a:ln/>
+        </p:spPr>
+        <p:txBody>
+          <a:bodyPr/>
+          <a:p/>
+        </p:txBody>
+      </p:sp>
+      <p:sp>
+        <p:nvSpPr>
+          <p:cNvPr id="17" name="Shape 12"/>
+          <p:cNvSpPr/>
+          <p:nvPr/>
+        </p:nvSpPr>
+        <p:spPr>
+          <a:xfrm>
+            <a:off x="10157460" y="6793992"/>
+            <a:ext cx="2040636" cy="64008"/>
+          </a:xfrm>
+          <a:prstGeom prst="rect">
+            <a:avLst/>
+          </a:prstGeom>
+          <a:solidFill>
+            <a:srgbClr val="E1DD57"/>
+          </a:solidFill>
+          <a:ln/>
+        </p:spPr>
+        <p:txBody>
+          <a:bodyPr/>
+          <a:p/>
+        </p:txBody>
+      </p:sp>
+      <p:sp>
+        <p:nvSpPr>
+          <p:cNvPr id="18" name="TextBox 17"/>
+          <p:cNvSpPr txBox="1"/>
+          <p:nvPr/>
+        </p:nvSpPr>
+        <p:spPr>
+          <a:xfrm>
+            <a:off x="548640" y="320040"/>
+            <a:ext cx="11064240" cy="685800"/>
+          </a:xfrm>
+          <a:prstGeom prst="rect">
+            <a:avLst/>
+          </a:prstGeom>
+          <a:noFill/>
+        </p:spPr>
+        <p:txBody>
+          <a:bodyPr wrap="none">
+            <a:spAutoFit/>
+          </a:bodyPr>
+          <a:lstStyle/>
+          <a:p>
+            <a:r>
+              <a:rPr sz="3000" b="1">
+                <a:solidFill>
+                  <a:srgbClr val="01485C"/>
+                </a:solidFill>
+              </a:rPr>
+              <a:t>Summaries for site leads and area managers</a:t>
+            </a:r>
+          </a:p>
+        </p:txBody>
+      </p:sp>
+      <p:sp>
+        <p:nvSpPr>
+          <p:cNvPr id="19" name="Rounded Rectangle 18"/>
+          <p:cNvSpPr/>
+          <p:nvPr/>
+        </p:nvSpPr>
+        <p:spPr>
+          <a:xfrm>
+            <a:off x="9784080" y="384048"/>
+            <a:ext cx="1828800" cy="457200"/>
+          </a:xfrm>
+          <a:prstGeom prst="roundRect">
+            <a:avLst/>
+          </a:prstGeom>
+          <a:solidFill>
+            <a:srgbClr val="01485C"/>
+          </a:solidFill>
+          <a:ln>
+            <a:noFill/>
+          </a:ln>
+        </p:spPr>
+        <p:style>
+          <a:lnRef idx="1">
+            <a:schemeClr val="accent1"/>
+          </a:lnRef>
+          <a:fillRef idx="3">
+            <a:schemeClr val="accent1"/>
+          </a:fillRef>
+          <a:effectRef idx="2">
+            <a:schemeClr val="accent1"/>
+          </a:effectRef>
+          <a:fontRef idx="minor">
+            <a:schemeClr val="lt1"/>
+          </a:fontRef>
+        </p:style>
+        <p:txBody>
+          <a:bodyPr rtlCol="0" anchor="ctr"/>
+          <a:lstStyle/>
+          <a:p>
+            <a:pPr algn="ctr"/>
+            <a:r>
+              <a:rPr sz="1500" b="1">
+                <a:solidFill>
+                  <a:srgbClr val="FFFFFF"/>
+                </a:solidFill>
+              </a:rPr>
+              <a:t>i-STAT</a:t>
+            </a:r>
+          </a:p>
+        </p:txBody>
+      </p:sp>
+      <p:pic>
+        <p:nvPicPr>
+          <p:cNvPr id="20" name="Picture 19" descr="site_p1.png"/>
+          <p:cNvPicPr>
+            <a:picLocks noChangeAspect="1"/>
+          </p:cNvPicPr>
+          <p:nvPr/>
+        </p:nvPicPr>
+        <p:blipFill>
+          <a:blip r:embed="rId2"/>
+          <a:stretch>
+            <a:fillRect/>
+          </a:stretch>
+        </p:blipFill>
+        <p:spPr>
+          <a:xfrm>
+            <a:off x="548640" y="1143000"/>
+            <a:ext cx="3429521" cy="4846320"/>
+          </a:xfrm>
+          <a:prstGeom prst="rect">
+            <a:avLst/>
+          </a:prstGeom>
+          <a:ln>
+            <a:solidFill>
+              <a:srgbClr val="E2E8EA"/>
+            </a:solidFill>
+          </a:ln>
+        </p:spPr>
+      </p:pic>
+      <p:sp>
+        <p:nvSpPr>
+          <p:cNvPr id="21" name="TextBox 20"/>
+          <p:cNvSpPr txBox="1"/>
+          <p:nvPr/>
+        </p:nvSpPr>
+        <p:spPr>
+          <a:xfrm>
+            <a:off x="548640" y="6035040"/>
+            <a:ext cx="3429521" cy="365760"/>
+          </a:xfrm>
+          <a:prstGeom prst="rect">
+            <a:avLst/>
+          </a:prstGeom>
+          <a:noFill/>
+        </p:spPr>
+        <p:txBody>
+          <a:bodyPr wrap="square">
+            <a:spAutoFit/>
+          </a:bodyPr>
+          <a:lstStyle/>
+          <a:p>
+            <a:pPr algn="ctr">
+              <a:spcAft>
+                <a:spcPts val="600"/>
+              </a:spcAft>
+            </a:pPr>
+            <a:r>
+              <a:rPr sz="1100" b="0">
+                <a:solidFill>
+                  <a:srgbClr val="5F7178"/>
+                </a:solidFill>
+              </a:rPr>
+              <a:t>Site Overview — every ward of a large site on one page</a:t>
+            </a:r>
+          </a:p>
+        </p:txBody>
+      </p:sp>
+      <p:pic>
+        <p:nvPicPr>
+          <p:cNvPr id="22" name="Picture 21" descr="area_p1.png"/>
+          <p:cNvPicPr>
+            <a:picLocks noChangeAspect="1"/>
+          </p:cNvPicPr>
+          <p:nvPr/>
+        </p:nvPicPr>
+        <p:blipFill>
+          <a:blip r:embed="rId3"/>
+          <a:stretch>
+            <a:fillRect/>
+          </a:stretch>
+        </p:blipFill>
+        <p:spPr>
+          <a:xfrm>
+            <a:off x="4206240" y="1143000"/>
+            <a:ext cx="3429521" cy="4846320"/>
+          </a:xfrm>
+          <a:prstGeom prst="rect">
+            <a:avLst/>
+          </a:prstGeom>
+          <a:ln>
+            <a:solidFill>
+              <a:srgbClr val="E2E8EA"/>
+            </a:solidFill>
+          </a:ln>
+        </p:spPr>
+      </p:pic>
+      <p:sp>
+        <p:nvSpPr>
+          <p:cNvPr id="23" name="TextBox 22"/>
+          <p:cNvSpPr txBox="1"/>
+          <p:nvPr/>
+        </p:nvSpPr>
+        <p:spPr>
+          <a:xfrm>
+            <a:off x="4206240" y="6035040"/>
+            <a:ext cx="3429521" cy="365760"/>
+          </a:xfrm>
+          <a:prstGeom prst="rect">
+            <a:avLst/>
+          </a:prstGeom>
+          <a:noFill/>
+        </p:spPr>
+        <p:txBody>
+          <a:bodyPr wrap="square">
+            <a:spAutoFit/>
+          </a:bodyPr>
+          <a:lstStyle/>
+          <a:p>
+            <a:pPr algn="ctr">
+              <a:spcAft>
+                <a:spcPts val="600"/>
+              </a:spcAft>
+            </a:pPr>
+            <a:r>
+              <a:rPr sz="1100" b="0">
+                <a:solidFill>
+                  <a:srgbClr val="5F7178"/>
+                </a:solidFill>
+              </a:rPr>
+              <a:t>Area Summary — every hospital in the HHS</a:t>
+            </a:r>
+          </a:p>
+        </p:txBody>
+      </p:sp>
+      <p:sp>
+        <p:nvSpPr>
+          <p:cNvPr id="24" name="TextBox 23"/>
+          <p:cNvSpPr txBox="1"/>
+          <p:nvPr/>
+        </p:nvSpPr>
+        <p:spPr>
+          <a:xfrm>
+            <a:off x="8046720" y="1188720"/>
+            <a:ext cx="3566160" cy="4846320"/>
+          </a:xfrm>
+          <a:prstGeom prst="rect">
+            <a:avLst/>
+          </a:prstGeom>
+          <a:noFill/>
+        </p:spPr>
+        <p:txBody>
+          <a:bodyPr wrap="square">
+            <a:spAutoFit/>
+          </a:bodyPr>
+          <a:lstStyle/>
+          <a:p>
+            <a:pPr algn="l">
+              <a:spcAft>
+                <a:spcPts val="600"/>
+              </a:spcAft>
+            </a:pPr>
+            <a:r>
+              <a:rPr sz="1500" b="1">
+                <a:solidFill>
+                  <a:srgbClr val="01485C"/>
+                </a:solidFill>
+              </a:rPr>
+              <a:t>The whole picture on one page</a:t>
+            </a:r>
+          </a:p>
+          <a:p>
+            <a:pPr algn="l">
+              <a:spcAft>
+                <a:spcPts val="600"/>
+              </a:spcAft>
+            </a:pPr>
+            <a:r>
+              <a:rPr sz="1200" b="0">
+                <a:solidFill>
+                  <a:srgbClr val="17272E"/>
+                </a:solidFill>
+              </a:rPr>
+              <a:t>Site Overview: each ward’s analyser with cartridges, errors, error %, performance band, simulator runs and a ceramic pass or fail, plus a site total.</a:t>
+            </a:r>
+          </a:p>
+          <a:p>
+            <a:pPr algn="l">
+              <a:spcAft>
+                <a:spcPts val="600"/>
+              </a:spcAft>
+            </a:pPr>
+            <a:r>
+              <a:rPr sz="1200" b="0">
+                <a:solidFill>
+                  <a:srgbClr val="17272E"/>
+                </a:solidFill>
+              </a:rPr>
+              <a:t>Area Summary: the same figures per hospital across the HHS, an area total, and a table of every analyser that missed simulators or ceramics.</a:t>
+            </a:r>
+          </a:p>
+          <a:p>
+            <a:pPr algn="l">
+              <a:spcAft>
+                <a:spcPts val="600"/>
+              </a:spcAft>
+            </a:pPr>
+            <a:r>
+              <a:rPr sz="1200" b="0">
+                <a:solidFill>
+                  <a:srgbClr val="17272E"/>
+                </a:solidFill>
+              </a:rPr>
+              <a:t>Both are produced automatically with every run, in the same folder as the reports.</a:t>
+            </a:r>
+          </a:p>
+        </p:txBody>
+      </p:sp>
+      <p:sp>
+        <p:nvSpPr>
+          <p:cNvPr id="25" name="TextBox 24"/>
+          <p:cNvSpPr txBox="1"/>
+          <p:nvPr/>
+        </p:nvSpPr>
+        <p:spPr>
+          <a:xfrm>
+            <a:off x="548640" y="6263640"/>
+            <a:ext cx="11064240" cy="365760"/>
+          </a:xfrm>
+          <a:prstGeom prst="rect">
+            <a:avLst/>
+          </a:prstGeom>
+          <a:noFill/>
+        </p:spPr>
+        <p:txBody>
+          <a:bodyPr wrap="square">
+            <a:spAutoFit/>
+          </a:bodyPr>
+          <a:lstStyle/>
+          <a:p>
+            <a:pPr algn="l">
+              <a:spcAft>
+                <a:spcPts val="600"/>
+              </a:spcAft>
+            </a:pPr>
+            <a:r>
+              <a:rPr sz="1100" b="0">
+                <a:solidFill>
+                  <a:srgbClr val="5F7178"/>
+                </a:solidFill>
+              </a:rPr>
+              <a:t>Conceived, designed and built by Craig MacKenzie · Chemistry Department, Townsville Group Laboratory · Pathology Queensland</a:t>
+            </a:r>
+          </a:p>
+        </p:txBody>
+      </p:sp>
+    </p:spTree>
+  </p:cSld>
+  <p:clrMapOvr>
+    <a:masterClrMapping/>
+  </p:clrMapOvr>
+</p:sld>
+</file>
+
+<file path=ppt/slides/slide12.xml><?xml version="1.0" encoding="utf-8"?>
+<p:sld xmlns:a="http://schemas.openxmlformats.org/drawingml/2006/main" xmlns:p="http://schemas.openxmlformats.org/presentationml/2006/main" xmlns:r="http://schemas.openxmlformats.org/officeDocument/2006/relationships">
+  <p:cSld>
+    <p:spTree>
+      <p:nvGrpSpPr>
+        <p:cNvPr id="1" name=""/>
+        <p:cNvGrpSpPr/>
+        <p:nvPr/>
+      </p:nvGrpSpPr>
+      <p:grpSpPr/>
+      <p:sp>
+        <p:nvSpPr>
+          <p:cNvPr id="12" name="Shape 7"/>
+          <p:cNvSpPr/>
+          <p:nvPr/>
+        </p:nvSpPr>
+        <p:spPr>
+          <a:xfrm>
+            <a:off x="0" y="6793992"/>
+            <a:ext cx="2040636" cy="64008"/>
+          </a:xfrm>
+          <a:prstGeom prst="rect">
+            <a:avLst/>
+          </a:prstGeom>
+          <a:solidFill>
+            <a:srgbClr val="01485C"/>
+          </a:solidFill>
+          <a:ln/>
+        </p:spPr>
+        <p:txBody>
+          <a:bodyPr/>
+          <a:p/>
+        </p:txBody>
+      </p:sp>
+      <p:sp>
+        <p:nvSpPr>
+          <p:cNvPr id="13" name="Shape 8"/>
+          <p:cNvSpPr/>
+          <p:nvPr/>
+        </p:nvSpPr>
+        <p:spPr>
+          <a:xfrm>
+            <a:off x="2031492" y="6793992"/>
+            <a:ext cx="2040636" cy="64008"/>
+          </a:xfrm>
+          <a:prstGeom prst="rect">
+            <a:avLst/>
+          </a:prstGeom>
+          <a:solidFill>
+            <a:srgbClr val="146175"/>
+          </a:solidFill>
+          <a:ln/>
+        </p:spPr>
+        <p:txBody>
+          <a:bodyPr/>
+          <a:p/>
+        </p:txBody>
+      </p:sp>
+      <p:sp>
+        <p:nvSpPr>
+          <p:cNvPr id="14" name="Shape 9"/>
+          <p:cNvSpPr/>
+          <p:nvPr/>
+        </p:nvSpPr>
+        <p:spPr>
+          <a:xfrm>
+            <a:off x="4062984" y="6793992"/>
+            <a:ext cx="2040636" cy="64008"/>
+          </a:xfrm>
+          <a:prstGeom prst="rect">
+            <a:avLst/>
+          </a:prstGeom>
+          <a:solidFill>
+            <a:srgbClr val="11B5AE"/>
+          </a:solidFill>
+          <a:ln/>
+        </p:spPr>
+        <p:txBody>
+          <a:bodyPr/>
+          <a:p/>
+        </p:txBody>
+      </p:sp>
+      <p:sp>
+        <p:nvSpPr>
+          <p:cNvPr id="15" name="Shape 10"/>
+          <p:cNvSpPr/>
+          <p:nvPr/>
+        </p:nvSpPr>
+        <p:spPr>
+          <a:xfrm>
+            <a:off x="6094476" y="6793992"/>
+            <a:ext cx="2040636" cy="64008"/>
+          </a:xfrm>
+          <a:prstGeom prst="rect">
+            <a:avLst/>
+          </a:prstGeom>
+          <a:solidFill>
+            <a:srgbClr val="6CCAD4"/>
+          </a:solidFill>
+          <a:ln/>
+        </p:spPr>
+        <p:txBody>
+          <a:bodyPr/>
+          <a:p/>
+        </p:txBody>
+      </p:sp>
+      <p:sp>
+        <p:nvSpPr>
+          <p:cNvPr id="16" name="Shape 11"/>
+          <p:cNvSpPr/>
+          <p:nvPr/>
+        </p:nvSpPr>
+        <p:spPr>
+          <a:xfrm>
+            <a:off x="8125968" y="6793992"/>
+            <a:ext cx="2040636" cy="64008"/>
+          </a:xfrm>
+          <a:prstGeom prst="rect">
+            <a:avLst/>
+          </a:prstGeom>
+          <a:solidFill>
+            <a:srgbClr val="7FC04C"/>
+          </a:solidFill>
+          <a:ln/>
+        </p:spPr>
+        <p:txBody>
+          <a:bodyPr/>
+          <a:p/>
+        </p:txBody>
+      </p:sp>
+      <p:sp>
+        <p:nvSpPr>
+          <p:cNvPr id="17" name="Shape 12"/>
+          <p:cNvSpPr/>
+          <p:nvPr/>
+        </p:nvSpPr>
+        <p:spPr>
+          <a:xfrm>
+            <a:off x="10157460" y="6793992"/>
+            <a:ext cx="2040636" cy="64008"/>
+          </a:xfrm>
+          <a:prstGeom prst="rect">
+            <a:avLst/>
+          </a:prstGeom>
+          <a:solidFill>
+            <a:srgbClr val="E1DD57"/>
+          </a:solidFill>
+          <a:ln/>
+        </p:spPr>
+        <p:txBody>
+          <a:bodyPr/>
+          <a:p/>
+        </p:txBody>
+      </p:sp>
+      <p:sp>
+        <p:nvSpPr>
+          <p:cNvPr id="18" name="TextBox 17"/>
+          <p:cNvSpPr txBox="1"/>
+          <p:nvPr/>
+        </p:nvSpPr>
+        <p:spPr>
+          <a:xfrm>
+            <a:off x="548640" y="320040"/>
+            <a:ext cx="11064240" cy="685800"/>
+          </a:xfrm>
+          <a:prstGeom prst="rect">
+            <a:avLst/>
+          </a:prstGeom>
+          <a:noFill/>
+        </p:spPr>
+        <p:txBody>
+          <a:bodyPr wrap="none">
+            <a:spAutoFit/>
+          </a:bodyPr>
+          <a:lstStyle/>
+          <a:p>
+            <a:r>
+              <a:rPr sz="3000" b="1">
+                <a:solidFill>
+                  <a:srgbClr val="01485C"/>
+                </a:solidFill>
+              </a:rPr>
+              <a:t>Dormant analysers — found, left out, listed</a:t>
+            </a:r>
+          </a:p>
+        </p:txBody>
+      </p:sp>
+      <p:sp>
+        <p:nvSpPr>
+          <p:cNvPr id="19" name="Rounded Rectangle 18"/>
+          <p:cNvSpPr/>
+          <p:nvPr/>
+        </p:nvSpPr>
+        <p:spPr>
+          <a:xfrm>
+            <a:off x="9784080" y="384048"/>
+            <a:ext cx="1828800" cy="457200"/>
+          </a:xfrm>
+          <a:prstGeom prst="roundRect">
+            <a:avLst/>
+          </a:prstGeom>
+          <a:solidFill>
+            <a:srgbClr val="01485C"/>
+          </a:solidFill>
+          <a:ln>
+            <a:noFill/>
+          </a:ln>
+        </p:spPr>
+        <p:style>
+          <a:lnRef idx="1">
+            <a:schemeClr val="accent1"/>
+          </a:lnRef>
+          <a:fillRef idx="3">
+            <a:schemeClr val="accent1"/>
+          </a:fillRef>
+          <a:effectRef idx="2">
+            <a:schemeClr val="accent1"/>
+          </a:effectRef>
+          <a:fontRef idx="minor">
+            <a:schemeClr val="lt1"/>
+          </a:fontRef>
+        </p:style>
+        <p:txBody>
+          <a:bodyPr rtlCol="0" anchor="ctr"/>
+          <a:lstStyle/>
+          <a:p>
+            <a:pPr algn="ctr"/>
+            <a:r>
+              <a:rPr sz="1500" b="1">
+                <a:solidFill>
+                  <a:srgbClr val="FFFFFF"/>
+                </a:solidFill>
+              </a:rPr>
+              <a:t>i-STAT</a:t>
+            </a:r>
+          </a:p>
+        </p:txBody>
+      </p:sp>
+      <p:pic>
+        <p:nvPicPr>
+          <p:cNvPr id="20" name="Picture 19" descr="dormant_p1.png"/>
+          <p:cNvPicPr>
+            <a:picLocks noChangeAspect="1"/>
+          </p:cNvPicPr>
+          <p:nvPr/>
+        </p:nvPicPr>
+        <p:blipFill>
+          <a:blip r:embed="rId2"/>
+          <a:stretch>
+            <a:fillRect/>
+          </a:stretch>
+        </p:blipFill>
+        <p:spPr>
+          <a:xfrm>
+            <a:off x="548640" y="1143000"/>
+            <a:ext cx="3429521" cy="4846320"/>
+          </a:xfrm>
+          <a:prstGeom prst="rect">
+            <a:avLst/>
+          </a:prstGeom>
+          <a:ln>
+            <a:solidFill>
+              <a:srgbClr val="E2E8EA"/>
+            </a:solidFill>
+          </a:ln>
+        </p:spPr>
+      </p:pic>
+      <p:sp>
+        <p:nvSpPr>
+          <p:cNvPr id="21" name="TextBox 20"/>
+          <p:cNvSpPr txBox="1"/>
+          <p:nvPr/>
+        </p:nvSpPr>
+        <p:spPr>
+          <a:xfrm>
+            <a:off x="548640" y="6035040"/>
+            <a:ext cx="3429521" cy="365760"/>
+          </a:xfrm>
+          <a:prstGeom prst="rect">
+            <a:avLst/>
+          </a:prstGeom>
+          <a:noFill/>
+        </p:spPr>
+        <p:txBody>
+          <a:bodyPr wrap="square">
+            <a:spAutoFit/>
+          </a:bodyPr>
+          <a:lstStyle/>
+          <a:p>
+            <a:pPr algn="ctr">
+              <a:spcAft>
+                <a:spcPts val="600"/>
+              </a:spcAft>
+            </a:pPr>
+            <a:r>
+              <a:rPr sz="1100" b="0">
+                <a:solidFill>
+                  <a:srgbClr val="5F7178"/>
+                </a:solidFill>
+              </a:rPr>
+              <a:t>The dormant-analyser list for August 2026</a:t>
+            </a:r>
+          </a:p>
+        </p:txBody>
+      </p:sp>
+      <p:sp>
+        <p:nvSpPr>
+          <p:cNvPr id="22" name="TextBox 21"/>
+          <p:cNvSpPr txBox="1"/>
+          <p:nvPr/>
+        </p:nvSpPr>
+        <p:spPr>
+          <a:xfrm>
+            <a:off x="4480560" y="1188720"/>
+            <a:ext cx="7132320" cy="4846320"/>
+          </a:xfrm>
+          <a:prstGeom prst="rect">
+            <a:avLst/>
+          </a:prstGeom>
+          <a:noFill/>
+        </p:spPr>
+        <p:txBody>
+          <a:bodyPr wrap="square">
+            <a:spAutoFit/>
+          </a:bodyPr>
+          <a:lstStyle/>
+          <a:p>
+            <a:pPr algn="l">
+              <a:spcAft>
+                <a:spcPts val="600"/>
+              </a:spcAft>
+            </a:pPr>
+            <a:r>
+              <a:rPr sz="1500" b="1">
+                <a:solidFill>
+                  <a:srgbClr val="01485C"/>
+                </a:solidFill>
+              </a:rPr>
+              <a:t>The four-month rule</a:t>
+            </a:r>
+          </a:p>
+          <a:p>
+            <a:pPr algn="l">
+              <a:spcAft>
+                <a:spcPts val="600"/>
+              </a:spcAft>
+            </a:pPr>
+            <a:r>
+              <a:rPr sz="1200" b="0">
+                <a:solidFill>
+                  <a:srgbClr val="17272E"/>
+                </a:solidFill>
+              </a:rPr>
+              <a:t>An analyser with no cartridges, no simulator runs and no ceramic cleaning for four consecutive months is dormant: it gets no report and no longer counts against its site’s checks.</a:t>
+            </a:r>
+          </a:p>
+          <a:p>
+            <a:pPr algn="l">
+              <a:spcAft>
+                <a:spcPts val="600"/>
+              </a:spcAft>
+            </a:pPr>
+            <a:r>
+              <a:rPr sz="1200" b="0">
+                <a:solidFill>
+                  <a:srgbClr val="17272E"/>
+                </a:solidFill>
+              </a:rPr>
+              <a:t>One or two quiet months change nothing. The reports exist to catch wards skipping simulators, so nothing is removed early.</a:t>
+            </a:r>
+          </a:p>
+          <a:p>
+            <a:pPr algn="l">
+              <a:spcAft>
+                <a:spcPts val="600"/>
+              </a:spcAft>
+            </a:pPr>
+            <a:r>
+              <a:rPr sz="1200" b="0">
+                <a:solidFill>
+                  <a:srgbClr val="17272E"/>
+                </a:solidFill>
+              </a:rPr>
+              <a:t>Any use brings the unit straight back the next month.</a:t>
+            </a:r>
+          </a:p>
+          <a:p>
+            <a:pPr algn="l">
+              <a:spcAft>
+                <a:spcPts val="600"/>
+              </a:spcAft>
+            </a:pPr>
+            <a:r>
+              <a:rPr sz="1200" b="0">
+                <a:solidFill>
+                  <a:srgbClr val="17272E"/>
+                </a:solidFill>
+              </a:rPr>
+              <a:t>Every run writes the list: hospital, location, serial, months idle and last activity. In August 2026, 163 units — mostly old models sitting beside their replacements — a ready-made retirement list.</a:t>
+            </a:r>
+          </a:p>
+        </p:txBody>
+      </p:sp>
+      <p:sp>
+        <p:nvSpPr>
+          <p:cNvPr id="23" name="TextBox 22"/>
+          <p:cNvSpPr txBox="1"/>
+          <p:nvPr/>
+        </p:nvSpPr>
+        <p:spPr>
+          <a:xfrm>
+            <a:off x="548640" y="6263640"/>
+            <a:ext cx="11064240" cy="365760"/>
+          </a:xfrm>
+          <a:prstGeom prst="rect">
+            <a:avLst/>
+          </a:prstGeom>
+          <a:noFill/>
+        </p:spPr>
+        <p:txBody>
+          <a:bodyPr wrap="square">
+            <a:spAutoFit/>
+          </a:bodyPr>
+          <a:lstStyle/>
+          <a:p>
+            <a:pPr algn="l">
+              <a:spcAft>
+                <a:spcPts val="600"/>
+              </a:spcAft>
+            </a:pPr>
+            <a:r>
+              <a:rPr sz="1100" b="0">
+                <a:solidFill>
+                  <a:srgbClr val="5F7178"/>
+                </a:solidFill>
+              </a:rPr>
+              <a:t>Conceived, designed and built by Craig MacKenzie · Chemistry Department, Townsville Group Laboratory · Pathology Queensland</a:t>
+            </a:r>
+          </a:p>
+        </p:txBody>
+      </p:sp>
+    </p:spTree>
+  </p:cSld>
+  <p:clrMapOvr>
+    <a:masterClrMapping/>
+  </p:clrMapOvr>
+</p:sld>
+</file>
+
+<file path=ppt/slides/slide13.xml><?xml version="1.0" encoding="utf-8"?>
+<p:sld xmlns:a="http://schemas.openxmlformats.org/drawingml/2006/main" xmlns:p="http://schemas.openxmlformats.org/presentationml/2006/main" xmlns:r="http://schemas.openxmlformats.org/officeDocument/2006/relationships">
+  <p:cSld>
+    <p:spTree>
+      <p:nvGrpSpPr>
+        <p:cNvPr id="1" name=""/>
+        <p:cNvGrpSpPr/>
+        <p:nvPr/>
+      </p:nvGrpSpPr>
+      <p:grpSpPr/>
+      <p:sp>
+        <p:nvSpPr>
+          <p:cNvPr id="12" name="Shape 7"/>
+          <p:cNvSpPr/>
+          <p:nvPr/>
+        </p:nvSpPr>
+        <p:spPr>
+          <a:xfrm>
+            <a:off x="0" y="6793992"/>
+            <a:ext cx="2040636" cy="64008"/>
+          </a:xfrm>
+          <a:prstGeom prst="rect">
+            <a:avLst/>
+          </a:prstGeom>
+          <a:solidFill>
+            <a:srgbClr val="01485C"/>
+          </a:solidFill>
+          <a:ln/>
+        </p:spPr>
+        <p:txBody>
+          <a:bodyPr/>
+          <a:p/>
+        </p:txBody>
+      </p:sp>
+      <p:sp>
+        <p:nvSpPr>
+          <p:cNvPr id="13" name="Shape 8"/>
+          <p:cNvSpPr/>
+          <p:nvPr/>
+        </p:nvSpPr>
+        <p:spPr>
+          <a:xfrm>
+            <a:off x="2031492" y="6793992"/>
+            <a:ext cx="2040636" cy="64008"/>
+          </a:xfrm>
+          <a:prstGeom prst="rect">
+            <a:avLst/>
+          </a:prstGeom>
+          <a:solidFill>
+            <a:srgbClr val="146175"/>
+          </a:solidFill>
+          <a:ln/>
+        </p:spPr>
+        <p:txBody>
+          <a:bodyPr/>
+          <a:p/>
+        </p:txBody>
+      </p:sp>
+      <p:sp>
+        <p:nvSpPr>
+          <p:cNvPr id="14" name="Shape 9"/>
+          <p:cNvSpPr/>
+          <p:nvPr/>
+        </p:nvSpPr>
+        <p:spPr>
+          <a:xfrm>
+            <a:off x="4062984" y="6793992"/>
+            <a:ext cx="2040636" cy="64008"/>
+          </a:xfrm>
+          <a:prstGeom prst="rect">
+            <a:avLst/>
+          </a:prstGeom>
+          <a:solidFill>
+            <a:srgbClr val="11B5AE"/>
+          </a:solidFill>
+          <a:ln/>
+        </p:spPr>
+        <p:txBody>
+          <a:bodyPr/>
+          <a:p/>
+        </p:txBody>
+      </p:sp>
+      <p:sp>
+        <p:nvSpPr>
+          <p:cNvPr id="15" name="Shape 10"/>
+          <p:cNvSpPr/>
+          <p:nvPr/>
+        </p:nvSpPr>
+        <p:spPr>
+          <a:xfrm>
+            <a:off x="6094476" y="6793992"/>
+            <a:ext cx="2040636" cy="64008"/>
+          </a:xfrm>
+          <a:prstGeom prst="rect">
+            <a:avLst/>
+          </a:prstGeom>
+          <a:solidFill>
+            <a:srgbClr val="6CCAD4"/>
+          </a:solidFill>
+          <a:ln/>
+        </p:spPr>
+        <p:txBody>
+          <a:bodyPr/>
+          <a:p/>
+        </p:txBody>
+      </p:sp>
+      <p:sp>
+        <p:nvSpPr>
+          <p:cNvPr id="16" name="Shape 11"/>
+          <p:cNvSpPr/>
+          <p:nvPr/>
+        </p:nvSpPr>
+        <p:spPr>
+          <a:xfrm>
+            <a:off x="8125968" y="6793992"/>
+            <a:ext cx="2040636" cy="64008"/>
+          </a:xfrm>
+          <a:prstGeom prst="rect">
+            <a:avLst/>
+          </a:prstGeom>
+          <a:solidFill>
+            <a:srgbClr val="7FC04C"/>
+          </a:solidFill>
+          <a:ln/>
+        </p:spPr>
+        <p:txBody>
+          <a:bodyPr/>
+          <a:p/>
+        </p:txBody>
+      </p:sp>
+      <p:sp>
+        <p:nvSpPr>
+          <p:cNvPr id="17" name="Shape 12"/>
+          <p:cNvSpPr/>
+          <p:nvPr/>
+        </p:nvSpPr>
+        <p:spPr>
+          <a:xfrm>
+            <a:off x="10157460" y="6793992"/>
+            <a:ext cx="2040636" cy="64008"/>
+          </a:xfrm>
+          <a:prstGeom prst="rect">
+            <a:avLst/>
+          </a:prstGeom>
+          <a:solidFill>
+            <a:srgbClr val="E1DD57"/>
+          </a:solidFill>
+          <a:ln/>
+        </p:spPr>
+        <p:txBody>
+          <a:bodyPr/>
+          <a:p/>
+        </p:txBody>
+      </p:sp>
+      <p:sp>
+        <p:nvSpPr>
+          <p:cNvPr id="18" name="TextBox 17"/>
+          <p:cNvSpPr txBox="1"/>
+          <p:nvPr/>
+        </p:nvSpPr>
+        <p:spPr>
+          <a:xfrm>
+            <a:off x="548640" y="320040"/>
+            <a:ext cx="11064240" cy="685800"/>
+          </a:xfrm>
+          <a:prstGeom prst="rect">
+            <a:avLst/>
+          </a:prstGeom>
+          <a:noFill/>
+        </p:spPr>
+        <p:txBody>
+          <a:bodyPr wrap="none">
+            <a:spAutoFit/>
+          </a:bodyPr>
+          <a:lstStyle/>
+          <a:p>
+            <a:r>
+              <a:rPr sz="3000" b="1">
+                <a:solidFill>
+                  <a:srgbClr val="01485C"/>
+                </a:solidFill>
+              </a:rPr>
+              <a:t>How it protects the data</a:t>
+            </a:r>
+          </a:p>
+        </p:txBody>
+      </p:sp>
+      <p:sp>
+        <p:nvSpPr>
+          <p:cNvPr id="19" name="Rounded Rectangle 18"/>
+          <p:cNvSpPr/>
+          <p:nvPr/>
+        </p:nvSpPr>
+        <p:spPr>
+          <a:xfrm>
+            <a:off x="548640" y="1280160"/>
+            <a:ext cx="5440680" cy="2103120"/>
+          </a:xfrm>
+          <a:prstGeom prst="roundRect">
+            <a:avLst>
+              <a:gd name="adj" fmla="val 8000"/>
+            </a:avLst>
+          </a:prstGeom>
+          <a:solidFill>
+            <a:srgbClr val="E5F2F0"/>
+          </a:solidFill>
+          <a:ln>
+            <a:noFill/>
+          </a:ln>
+        </p:spPr>
+        <p:style>
+          <a:lnRef idx="1">
+            <a:schemeClr val="accent1"/>
+          </a:lnRef>
+          <a:fillRef idx="3">
+            <a:schemeClr val="accent1"/>
+          </a:fillRef>
+          <a:effectRef idx="2">
+            <a:schemeClr val="accent1"/>
+          </a:effectRef>
+          <a:fontRef idx="minor">
+            <a:schemeClr val="lt1"/>
+          </a:fontRef>
+        </p:style>
+        <p:txBody>
+          <a:bodyPr rtlCol="0" anchor="ctr"/>
+          <a:lstStyle/>
+          <a:p>
+            <a:pPr algn="ctr"/>
+          </a:p>
+        </p:txBody>
+      </p:sp>
+      <p:sp>
+        <p:nvSpPr>
+          <p:cNvPr id="20" name="TextBox 19"/>
+          <p:cNvSpPr txBox="1"/>
+          <p:nvPr/>
+        </p:nvSpPr>
+        <p:spPr>
+          <a:xfrm>
+            <a:off x="777240" y="1417319"/>
+            <a:ext cx="4983480" cy="457200"/>
+          </a:xfrm>
+          <a:prstGeom prst="rect">
+            <a:avLst/>
+          </a:prstGeom>
+          <a:noFill/>
+        </p:spPr>
+        <p:txBody>
+          <a:bodyPr wrap="square">
+            <a:spAutoFit/>
+          </a:bodyPr>
+          <a:lstStyle/>
+          <a:p>
+            <a:pPr algn="l">
+              <a:spcAft>
+                <a:spcPts val="600"/>
+              </a:spcAft>
+            </a:pPr>
+            <a:r>
+              <a:rPr sz="1500" b="1">
+                <a:solidFill>
+                  <a:srgbClr val="01485C"/>
+                </a:solidFill>
+              </a:rPr>
+              <a:t>Runs from an encrypted USB drive</a:t>
+            </a:r>
+          </a:p>
+        </p:txBody>
+      </p:sp>
+      <p:sp>
+        <p:nvSpPr>
+          <p:cNvPr id="21" name="TextBox 20"/>
+          <p:cNvSpPr txBox="1"/>
+          <p:nvPr/>
+        </p:nvSpPr>
+        <p:spPr>
+          <a:xfrm>
+            <a:off x="777240" y="1847088"/>
+            <a:ext cx="4983480" cy="1463039"/>
+          </a:xfrm>
+          <a:prstGeom prst="rect">
+            <a:avLst/>
+          </a:prstGeom>
+          <a:noFill/>
+        </p:spPr>
+        <p:txBody>
+          <a:bodyPr wrap="square">
+            <a:spAutoFit/>
+          </a:bodyPr>
+          <a:lstStyle/>
+          <a:p>
+            <a:pPr algn="l">
+              <a:spcAft>
+                <a:spcPts val="600"/>
+              </a:spcAft>
+            </a:pPr>
+            <a:r>
+              <a:rPr sz="1200" b="0">
+                <a:solidFill>
+                  <a:srgbClr val="17272E"/>
+                </a:solidFill>
+              </a:rPr>
+              <a:t>Its own Python runtime, no installation, no admin rights, no changes to the PC. BitLocker To Go encrypts the whole drive.</a:t>
+            </a:r>
+          </a:p>
+        </p:txBody>
+      </p:sp>
+      <p:sp>
+        <p:nvSpPr>
+          <p:cNvPr id="22" name="Rounded Rectangle 21"/>
+          <p:cNvSpPr/>
+          <p:nvPr/>
+        </p:nvSpPr>
+        <p:spPr>
+          <a:xfrm>
+            <a:off x="6172200" y="1280160"/>
+            <a:ext cx="5440680" cy="2103120"/>
+          </a:xfrm>
+          <a:prstGeom prst="roundRect">
+            <a:avLst>
+              <a:gd name="adj" fmla="val 8000"/>
+            </a:avLst>
+          </a:prstGeom>
+          <a:solidFill>
+            <a:srgbClr val="E5F2F0"/>
+          </a:solidFill>
+          <a:ln>
+            <a:noFill/>
+          </a:ln>
+        </p:spPr>
+        <p:style>
+          <a:lnRef idx="1">
+            <a:schemeClr val="accent1"/>
+          </a:lnRef>
+          <a:fillRef idx="3">
+            <a:schemeClr val="accent1"/>
+          </a:fillRef>
+          <a:effectRef idx="2">
+            <a:schemeClr val="accent1"/>
+          </a:effectRef>
+          <a:fontRef idx="minor">
+            <a:schemeClr val="lt1"/>
+          </a:fontRef>
+        </p:style>
+        <p:txBody>
+          <a:bodyPr rtlCol="0" anchor="ctr"/>
+          <a:lstStyle/>
+          <a:p>
+            <a:pPr algn="ctr"/>
+          </a:p>
+        </p:txBody>
+      </p:sp>
+      <p:sp>
+        <p:nvSpPr>
+          <p:cNvPr id="23" name="TextBox 22"/>
+          <p:cNvSpPr txBox="1"/>
+          <p:nvPr/>
+        </p:nvSpPr>
+        <p:spPr>
+          <a:xfrm>
+            <a:off x="6400800" y="1417319"/>
+            <a:ext cx="4983480" cy="457200"/>
+          </a:xfrm>
+          <a:prstGeom prst="rect">
+            <a:avLst/>
+          </a:prstGeom>
+          <a:noFill/>
+        </p:spPr>
+        <p:txBody>
+          <a:bodyPr wrap="square">
+            <a:spAutoFit/>
+          </a:bodyPr>
+          <a:lstStyle/>
+          <a:p>
+            <a:pPr algn="l">
+              <a:spcAft>
+                <a:spcPts val="600"/>
+              </a:spcAft>
+            </a:pPr>
+            <a:r>
+              <a:rPr sz="1500" b="1">
+                <a:solidFill>
+                  <a:srgbClr val="01485C"/>
+                </a:solidFill>
+              </a:rPr>
+              <a:t>Offline by enforcement</a:t>
+            </a:r>
+          </a:p>
+        </p:txBody>
+      </p:sp>
+      <p:sp>
+        <p:nvSpPr>
+          <p:cNvPr id="24" name="TextBox 23"/>
+          <p:cNvSpPr txBox="1"/>
+          <p:nvPr/>
+        </p:nvSpPr>
+        <p:spPr>
+          <a:xfrm>
+            <a:off x="6400800" y="1847088"/>
+            <a:ext cx="4983480" cy="1463039"/>
+          </a:xfrm>
+          <a:prstGeom prst="rect">
+            <a:avLst/>
+          </a:prstGeom>
+          <a:noFill/>
+        </p:spPr>
+        <p:txBody>
+          <a:bodyPr wrap="square">
+            <a:spAutoFit/>
+          </a:bodyPr>
+          <a:lstStyle/>
+          <a:p>
+            <a:pPr algn="l">
+              <a:spcAft>
+                <a:spcPts val="600"/>
+              </a:spcAft>
+            </a:pPr>
+            <a:r>
+              <a:rPr sz="1200" b="0">
+                <a:solidFill>
+                  <a:srgbClr val="17272E"/>
+                </a:solidFill>
+              </a:rPr>
+              <a:t>All three servers bind to the local machine only, and a runtime guard blocks and logs any attempt to reach the network. Zero outbound connections, ever.</a:t>
+            </a:r>
+          </a:p>
+        </p:txBody>
+      </p:sp>
+      <p:sp>
+        <p:nvSpPr>
+          <p:cNvPr id="25" name="Rounded Rectangle 24"/>
+          <p:cNvSpPr/>
+          <p:nvPr/>
+        </p:nvSpPr>
+        <p:spPr>
+          <a:xfrm>
+            <a:off x="548640" y="3566160"/>
+            <a:ext cx="5440680" cy="2103120"/>
+          </a:xfrm>
+          <a:prstGeom prst="roundRect">
+            <a:avLst>
+              <a:gd name="adj" fmla="val 8000"/>
+            </a:avLst>
+          </a:prstGeom>
+          <a:solidFill>
+            <a:srgbClr val="FDF0E4"/>
+          </a:solidFill>
+          <a:ln>
+            <a:noFill/>
+          </a:ln>
+        </p:spPr>
+        <p:style>
+          <a:lnRef idx="1">
+            <a:schemeClr val="accent1"/>
+          </a:lnRef>
+          <a:fillRef idx="3">
+            <a:schemeClr val="accent1"/>
+          </a:fillRef>
+          <a:effectRef idx="2">
+            <a:schemeClr val="accent1"/>
+          </a:effectRef>
+          <a:fontRef idx="minor">
+            <a:schemeClr val="lt1"/>
+          </a:fontRef>
+        </p:style>
+        <p:txBody>
+          <a:bodyPr rtlCol="0" anchor="ctr"/>
+          <a:lstStyle/>
+          <a:p>
+            <a:pPr algn="ctr"/>
+          </a:p>
+        </p:txBody>
+      </p:sp>
+      <p:sp>
+        <p:nvSpPr>
+          <p:cNvPr id="26" name="TextBox 25"/>
+          <p:cNvSpPr txBox="1"/>
+          <p:nvPr/>
+        </p:nvSpPr>
+        <p:spPr>
+          <a:xfrm>
+            <a:off x="777240" y="3703320"/>
+            <a:ext cx="4983480" cy="457200"/>
+          </a:xfrm>
+          <a:prstGeom prst="rect">
+            <a:avLst/>
+          </a:prstGeom>
+          <a:noFill/>
+        </p:spPr>
+        <p:txBody>
+          <a:bodyPr wrap="square">
+            <a:spAutoFit/>
+          </a:bodyPr>
+          <a:lstStyle/>
+          <a:p>
+            <a:pPr algn="l">
+              <a:spcAft>
+                <a:spcPts val="600"/>
+              </a:spcAft>
+            </a:pPr>
+            <a:r>
+              <a:rPr sz="1500" b="1">
+                <a:solidFill>
+                  <a:srgbClr val="B4540A"/>
+                </a:solidFill>
+              </a:rPr>
+              <a:t>Named staff data encrypted</a:t>
+            </a:r>
+          </a:p>
+        </p:txBody>
+      </p:sp>
+      <p:sp>
+        <p:nvSpPr>
+          <p:cNvPr id="27" name="TextBox 26"/>
+          <p:cNvSpPr txBox="1"/>
+          <p:nvPr/>
+        </p:nvSpPr>
+        <p:spPr>
+          <a:xfrm>
+            <a:off x="777240" y="4133087"/>
+            <a:ext cx="4983480" cy="1463039"/>
+          </a:xfrm>
+          <a:prstGeom prst="rect">
+            <a:avLst/>
+          </a:prstGeom>
+          <a:noFill/>
+        </p:spPr>
+        <p:txBody>
+          <a:bodyPr wrap="square">
+            <a:spAutoFit/>
+          </a:bodyPr>
+          <a:lstStyle/>
+          <a:p>
+            <a:pPr algn="l">
+              <a:spcAft>
+                <a:spcPts val="600"/>
+              </a:spcAft>
+            </a:pPr>
+            <a:r>
+              <a:rPr sz="1200" b="0">
+                <a:solidFill>
+                  <a:srgbClr val="17272E"/>
+                </a:solidFill>
+              </a:rPr>
+              <a:t>The rolling staff and device history is AES-encrypted with a password that is never stored. Reports cannot be generated until it is unlocked.</a:t>
+            </a:r>
+          </a:p>
+        </p:txBody>
+      </p:sp>
+      <p:sp>
+        <p:nvSpPr>
+          <p:cNvPr id="28" name="Rounded Rectangle 27"/>
+          <p:cNvSpPr/>
+          <p:nvPr/>
+        </p:nvSpPr>
+        <p:spPr>
+          <a:xfrm>
+            <a:off x="6172200" y="3566160"/>
+            <a:ext cx="5440680" cy="2103120"/>
+          </a:xfrm>
+          <a:prstGeom prst="roundRect">
+            <a:avLst>
+              <a:gd name="adj" fmla="val 8000"/>
+            </a:avLst>
+          </a:prstGeom>
+          <a:solidFill>
+            <a:srgbClr val="E5F2F0"/>
+          </a:solidFill>
+          <a:ln>
+            <a:noFill/>
+          </a:ln>
+        </p:spPr>
+        <p:style>
+          <a:lnRef idx="1">
+            <a:schemeClr val="accent1"/>
+          </a:lnRef>
+          <a:fillRef idx="3">
+            <a:schemeClr val="accent1"/>
+          </a:fillRef>
+          <a:effectRef idx="2">
+            <a:schemeClr val="accent1"/>
+          </a:effectRef>
+          <a:fontRef idx="minor">
+            <a:schemeClr val="lt1"/>
+          </a:fontRef>
+        </p:style>
+        <p:txBody>
+          <a:bodyPr rtlCol="0" anchor="ctr"/>
+          <a:lstStyle/>
+          <a:p>
+            <a:pPr algn="ctr"/>
+          </a:p>
+        </p:txBody>
+      </p:sp>
+      <p:sp>
+        <p:nvSpPr>
+          <p:cNvPr id="29" name="TextBox 28"/>
+          <p:cNvSpPr txBox="1"/>
+          <p:nvPr/>
+        </p:nvSpPr>
+        <p:spPr>
+          <a:xfrm>
+            <a:off x="6400800" y="3703320"/>
+            <a:ext cx="4983480" cy="457200"/>
+          </a:xfrm>
+          <a:prstGeom prst="rect">
+            <a:avLst/>
+          </a:prstGeom>
+          <a:noFill/>
+        </p:spPr>
+        <p:txBody>
+          <a:bodyPr wrap="square">
+            <a:spAutoFit/>
+          </a:bodyPr>
+          <a:lstStyle/>
+          <a:p>
+            <a:pPr algn="l">
+              <a:spcAft>
+                <a:spcPts val="600"/>
+              </a:spcAft>
+            </a:pPr>
+            <a:r>
+              <a:rPr sz="1500" b="1">
+                <a:solidFill>
+                  <a:srgbClr val="01485C"/>
+                </a:solidFill>
+              </a:rPr>
+              <a:t>Controlled roll-out</a:t>
+            </a:r>
+          </a:p>
+        </p:txBody>
+      </p:sp>
+      <p:sp>
+        <p:nvSpPr>
+          <p:cNvPr id="30" name="TextBox 29"/>
+          <p:cNvSpPr txBox="1"/>
+          <p:nvPr/>
+        </p:nvSpPr>
+        <p:spPr>
+          <a:xfrm>
+            <a:off x="6400800" y="4133087"/>
+            <a:ext cx="4983480" cy="1463039"/>
+          </a:xfrm>
+          <a:prstGeom prst="rect">
+            <a:avLst/>
+          </a:prstGeom>
+          <a:noFill/>
+        </p:spPr>
+        <p:txBody>
+          <a:bodyPr wrap="square">
+            <a:spAutoFit/>
+          </a:bodyPr>
+          <a:lstStyle/>
+          <a:p>
+            <a:pPr algn="l">
+              <a:spcAft>
+                <a:spcPts val="600"/>
+              </a:spcAft>
+            </a:pPr>
+            <a:r>
+              <a:rPr sz="1200" b="0">
+                <a:solidFill>
+                  <a:srgbClr val="17272E"/>
+                </a:solidFill>
+              </a:rPr>
+              <a:t>It runs only on PCs approved by the PoC lead, reviewed on the 12-month QIS cycle, with an audit trail of every launch and every report generated.</a:t>
+            </a:r>
+          </a:p>
+        </p:txBody>
+      </p:sp>
+      <p:sp>
+        <p:nvSpPr>
+          <p:cNvPr id="31" name="TextBox 30"/>
+          <p:cNvSpPr txBox="1"/>
+          <p:nvPr/>
+        </p:nvSpPr>
+        <p:spPr>
+          <a:xfrm>
+            <a:off x="548640" y="5806440"/>
+            <a:ext cx="11064240" cy="411480"/>
+          </a:xfrm>
+          <a:prstGeom prst="rect">
+            <a:avLst/>
+          </a:prstGeom>
+          <a:noFill/>
+        </p:spPr>
+        <p:txBody>
+          <a:bodyPr wrap="square">
+            <a:spAutoFit/>
+          </a:bodyPr>
+          <a:lstStyle/>
+          <a:p>
+            <a:pPr algn="l">
+              <a:spcAft>
+                <a:spcPts val="600"/>
+              </a:spcAft>
+            </a:pPr>
+            <a:r>
+              <a:rPr sz="1100" b="0">
+                <a:solidFill>
+                  <a:srgbClr val="5F7178"/>
+                </a:solidFill>
+              </a:rPr>
+              <a:t>Full detail for IT: SECURITY_README.md on the drive and the Security Briefing deck.</a:t>
+            </a:r>
+          </a:p>
+        </p:txBody>
+      </p:sp>
+      <p:sp>
+        <p:nvSpPr>
+          <p:cNvPr id="32" name="TextBox 31"/>
+          <p:cNvSpPr txBox="1"/>
+          <p:nvPr/>
+        </p:nvSpPr>
+        <p:spPr>
+          <a:xfrm>
+            <a:off x="548640" y="6263640"/>
+            <a:ext cx="11064240" cy="365760"/>
+          </a:xfrm>
+          <a:prstGeom prst="rect">
+            <a:avLst/>
+          </a:prstGeom>
+          <a:noFill/>
+        </p:spPr>
+        <p:txBody>
+          <a:bodyPr wrap="square">
+            <a:spAutoFit/>
+          </a:bodyPr>
+          <a:lstStyle/>
+          <a:p>
+            <a:pPr algn="l">
+              <a:spcAft>
+                <a:spcPts val="600"/>
+              </a:spcAft>
+            </a:pPr>
+            <a:r>
+              <a:rPr sz="1100" b="0">
+                <a:solidFill>
+                  <a:srgbClr val="5F7178"/>
+                </a:solidFill>
+              </a:rPr>
+              <a:t>Conceived, designed and built by Craig MacKenzie · Chemistry Department, Townsville Group Laboratory · Pathology Queensland</a:t>
+            </a:r>
+          </a:p>
+        </p:txBody>
+      </p:sp>
+    </p:spTree>
+  </p:cSld>
+  <p:clrMapOvr>
+    <a:masterClrMapping/>
+  </p:clrMapOvr>
+</p:sld>
+</file>
+
+<file path=ppt/slides/slide14.xml><?xml version="1.0" encoding="utf-8"?>
+<p:sld xmlns:a="http://schemas.openxmlformats.org/drawingml/2006/main" xmlns:p="http://schemas.openxmlformats.org/presentationml/2006/main" xmlns:r="http://schemas.openxmlformats.org/officeDocument/2006/relationships">
+  <p:cSld>
+    <p:spTree>
+      <p:nvGrpSpPr>
+        <p:cNvPr id="1" name=""/>
+        <p:cNvGrpSpPr/>
+        <p:nvPr/>
+      </p:nvGrpSpPr>
+      <p:grpSpPr/>
+      <p:sp>
+        <p:nvSpPr>
+          <p:cNvPr id="12" name="Shape 7"/>
+          <p:cNvSpPr/>
+          <p:nvPr/>
+        </p:nvSpPr>
+        <p:spPr>
+          <a:xfrm>
+            <a:off x="0" y="6793992"/>
+            <a:ext cx="2040636" cy="64008"/>
+          </a:xfrm>
+          <a:prstGeom prst="rect">
+            <a:avLst/>
+          </a:prstGeom>
+          <a:solidFill>
+            <a:srgbClr val="01485C"/>
+          </a:solidFill>
+          <a:ln/>
+        </p:spPr>
+        <p:txBody>
+          <a:bodyPr/>
+          <a:p/>
+        </p:txBody>
+      </p:sp>
+      <p:sp>
+        <p:nvSpPr>
+          <p:cNvPr id="13" name="Shape 8"/>
+          <p:cNvSpPr/>
+          <p:nvPr/>
+        </p:nvSpPr>
+        <p:spPr>
+          <a:xfrm>
+            <a:off x="2031492" y="6793992"/>
+            <a:ext cx="2040636" cy="64008"/>
+          </a:xfrm>
+          <a:prstGeom prst="rect">
+            <a:avLst/>
+          </a:prstGeom>
+          <a:solidFill>
+            <a:srgbClr val="146175"/>
+          </a:solidFill>
+          <a:ln/>
+        </p:spPr>
+        <p:txBody>
+          <a:bodyPr/>
+          <a:p/>
+        </p:txBody>
+      </p:sp>
+      <p:sp>
+        <p:nvSpPr>
+          <p:cNvPr id="14" name="Shape 9"/>
+          <p:cNvSpPr/>
+          <p:nvPr/>
+        </p:nvSpPr>
+        <p:spPr>
+          <a:xfrm>
+            <a:off x="4062984" y="6793992"/>
+            <a:ext cx="2040636" cy="64008"/>
+          </a:xfrm>
+          <a:prstGeom prst="rect">
+            <a:avLst/>
+          </a:prstGeom>
+          <a:solidFill>
+            <a:srgbClr val="11B5AE"/>
+          </a:solidFill>
+          <a:ln/>
+        </p:spPr>
+        <p:txBody>
+          <a:bodyPr/>
+          <a:p/>
+        </p:txBody>
+      </p:sp>
+      <p:sp>
+        <p:nvSpPr>
+          <p:cNvPr id="15" name="Shape 10"/>
+          <p:cNvSpPr/>
+          <p:nvPr/>
+        </p:nvSpPr>
+        <p:spPr>
+          <a:xfrm>
+            <a:off x="6094476" y="6793992"/>
+            <a:ext cx="2040636" cy="64008"/>
+          </a:xfrm>
+          <a:prstGeom prst="rect">
+            <a:avLst/>
+          </a:prstGeom>
+          <a:solidFill>
+            <a:srgbClr val="6CCAD4"/>
+          </a:solidFill>
+          <a:ln/>
+        </p:spPr>
+        <p:txBody>
+          <a:bodyPr/>
+          <a:p/>
+        </p:txBody>
+      </p:sp>
+      <p:sp>
+        <p:nvSpPr>
+          <p:cNvPr id="16" name="Shape 11"/>
+          <p:cNvSpPr/>
+          <p:nvPr/>
+        </p:nvSpPr>
+        <p:spPr>
+          <a:xfrm>
+            <a:off x="8125968" y="6793992"/>
+            <a:ext cx="2040636" cy="64008"/>
+          </a:xfrm>
+          <a:prstGeom prst="rect">
+            <a:avLst/>
+          </a:prstGeom>
+          <a:solidFill>
+            <a:srgbClr val="7FC04C"/>
+          </a:solidFill>
+          <a:ln/>
+        </p:spPr>
+        <p:txBody>
+          <a:bodyPr/>
+          <a:p/>
+        </p:txBody>
+      </p:sp>
+      <p:sp>
+        <p:nvSpPr>
+          <p:cNvPr id="17" name="Shape 12"/>
+          <p:cNvSpPr/>
+          <p:nvPr/>
+        </p:nvSpPr>
+        <p:spPr>
+          <a:xfrm>
+            <a:off x="10157460" y="6793992"/>
+            <a:ext cx="2040636" cy="64008"/>
+          </a:xfrm>
+          <a:prstGeom prst="rect">
+            <a:avLst/>
+          </a:prstGeom>
+          <a:solidFill>
+            <a:srgbClr val="E1DD57"/>
+          </a:solidFill>
+          <a:ln/>
+        </p:spPr>
+        <p:txBody>
+          <a:bodyPr/>
+          <a:p/>
+        </p:txBody>
+      </p:sp>
+      <p:sp>
+        <p:nvSpPr>
+          <p:cNvPr id="18" name="TextBox 17"/>
+          <p:cNvSpPr txBox="1"/>
+          <p:nvPr/>
+        </p:nvSpPr>
+        <p:spPr>
+          <a:xfrm>
+            <a:off x="548640" y="320040"/>
+            <a:ext cx="11064240" cy="685800"/>
+          </a:xfrm>
+          <a:prstGeom prst="rect">
+            <a:avLst/>
+          </a:prstGeom>
+          <a:noFill/>
+        </p:spPr>
+        <p:txBody>
+          <a:bodyPr wrap="none">
+            <a:spAutoFit/>
+          </a:bodyPr>
+          <a:lstStyle/>
+          <a:p>
+            <a:r>
+              <a:rPr sz="3000" b="1">
+                <a:solidFill>
+                  <a:srgbClr val="01485C"/>
+                </a:solidFill>
+              </a:rPr>
               <a:t>Getting the reports for your site</a:t>
             </a:r>
           </a:p>
@@ -3729,6 +5887,21 @@
               <a:t>Dormant_iSTATs_August2026.docx sits at the top level of the month folder — every analyser left out and why.</a:t>
             </a:r>
           </a:p>
+          <a:p>
+            <a:pPr algn="l">
+              <a:spcAft>
+                <a:spcPts val="600"/>
+              </a:spcAft>
+            </a:pPr>
+            <a:r>
+              <a:rPr sz="1100" b="0">
+                <a:solidFill>
+                  <a:srgbClr val="5F7178"/>
+                </a:solidFill>
+              </a:rPr>
+              <a:t>The ABL run adds 68 documents: 52 department reports and a Hospital Summary for each of 16 hospitals.</a:t>
+            </a:r>
+          </a:p>
         </p:txBody>
       </p:sp>
       <p:pic>
@@ -5487,7 +7660,7 @@
                   <a:srgbClr val="01485C"/>
                 </a:solidFill>
               </a:rPr>
-              <a:t>Summaries for site leads and area managers</a:t>
+              <a:t>ABL — Townsville ED, August 2026 — pages 1–2 of 5</a:t>
             </a:r>
           </a:p>
         </p:txBody>
@@ -5545,7 +7718,7 @@
       </p:sp>
       <p:pic>
         <p:nvPicPr>
-          <p:cNvPr id="20" name="Picture 19" descr="site_p1.png"/>
+          <p:cNvPr id="20" name="Picture 19" descr="abl_dept_p1.png"/>
           <p:cNvPicPr>
             <a:picLocks noChangeAspect="1"/>
           </p:cNvPicPr>
@@ -5605,14 +7778,14 @@
                   <a:srgbClr val="5F7178"/>
                 </a:solidFill>
               </a:rPr>
-              <a:t>Site Overview — every ward of a large site on one page</a:t>
+              <a:t>Page 1: department snapshot, first analyser trend</a:t>
             </a:r>
           </a:p>
         </p:txBody>
       </p:sp>
       <p:pic>
         <p:nvPicPr>
-          <p:cNvPr id="22" name="Picture 21" descr="area_p1.png"/>
+          <p:cNvPr id="22" name="Picture 21" descr="abl_dept_p2.png"/>
           <p:cNvPicPr>
             <a:picLocks noChangeAspect="1"/>
           </p:cNvPicPr>
@@ -5672,7 +7845,7 @@
                   <a:srgbClr val="5F7178"/>
                 </a:solidFill>
               </a:rPr>
-              <a:t>Area Summary — every hospital in the HHS</a:t>
+              <a:t>Page 2: tests and error mix, first analyser</a:t>
             </a:r>
           </a:p>
         </p:txBody>
@@ -5710,7 +7883,7 @@
                   <a:srgbClr val="01485C"/>
                 </a:solidFill>
               </a:rPr>
-              <a:t>The whole picture on one page</a:t>
+              <a:t>The ABL department report</a:t>
             </a:r>
           </a:p>
           <a:p>
@@ -5725,7 +7898,7 @@
                   <a:srgbClr val="17272E"/>
                 </a:solidFill>
               </a:rPr>
-              <a:t>Site Overview: each ward’s analyser with cartridges, errors, error %, performance band, simulator runs and a ceramic pass or fail, plus a site total.</a:t>
+              <a:t>One report per hospital department. Page 1 — Monthly Snapshot: department error rate with its band, the analysers covered, the top error code, operators with errors (and how many were too low-volume to assess), operators flagged this month by name, and recurring alerts from the 12-month lookback.</a:t>
             </a:r>
           </a:p>
           <a:p>
@@ -5740,7 +7913,7 @@
                   <a:srgbClr val="17272E"/>
                 </a:solidFill>
               </a:rPr>
-              <a:t>Area Summary: the same figures per hospital across the HHS, an area total, and a table of every analyser that missed simulators or ceramics.</a:t>
+              <a:t>Then the Error Rate Trend for the first analyser against the performance bands.</a:t>
             </a:r>
           </a:p>
           <a:p>
@@ -5755,7 +7928,7 @@
                   <a:srgbClr val="17272E"/>
                 </a:solidFill>
               </a:rPr>
-              <a:t>Both are produced automatically with every run, in the same folder as the reports.</a:t>
+              <a:t>Page 2 — Tests Run &amp; Error Mix for that analyser: workload on top, each month’s errors as a percentage of tests split by ABL error code, every segment labelled.</a:t>
             </a:r>
           </a:p>
         </p:txBody>
@@ -5988,7 +8161,7 @@
                   <a:srgbClr val="01485C"/>
                 </a:solidFill>
               </a:rPr>
-              <a:t>Dormant analysers — found, left out, listed</a:t>
+              <a:t>ABL — Townsville ED, August 2026 — pages 3–4 of 5</a:t>
             </a:r>
           </a:p>
         </p:txBody>
@@ -6046,7 +8219,7 @@
       </p:sp>
       <p:pic>
         <p:nvPicPr>
-          <p:cNvPr id="20" name="Picture 19" descr="dormant_p1.png"/>
+          <p:cNvPr id="20" name="Picture 19" descr="abl_dept_p3.png"/>
           <p:cNvPicPr>
             <a:picLocks noChangeAspect="1"/>
           </p:cNvPicPr>
@@ -6106,21 +8279,50 @@
                   <a:srgbClr val="5F7178"/>
                 </a:solidFill>
               </a:rPr>
-              <a:t>The dormant-analyser list for August 2026</a:t>
-            </a:r>
-          </a:p>
-        </p:txBody>
-      </p:sp>
-      <p:sp>
-        <p:nvSpPr>
-          <p:cNvPr id="22" name="TextBox 21"/>
+              <a:t>Page 3: second analyser trend</a:t>
+            </a:r>
+          </a:p>
+        </p:txBody>
+      </p:sp>
+      <p:pic>
+        <p:nvPicPr>
+          <p:cNvPr id="22" name="Picture 21" descr="abl_dept_p4.png"/>
+          <p:cNvPicPr>
+            <a:picLocks noChangeAspect="1"/>
+          </p:cNvPicPr>
+          <p:nvPr/>
+        </p:nvPicPr>
+        <p:blipFill>
+          <a:blip r:embed="rId3"/>
+          <a:stretch>
+            <a:fillRect/>
+          </a:stretch>
+        </p:blipFill>
+        <p:spPr>
+          <a:xfrm>
+            <a:off x="4206240" y="1143000"/>
+            <a:ext cx="3429521" cy="4846320"/>
+          </a:xfrm>
+          <a:prstGeom prst="rect">
+            <a:avLst/>
+          </a:prstGeom>
+          <a:ln>
+            <a:solidFill>
+              <a:srgbClr val="E2E8EA"/>
+            </a:solidFill>
+          </a:ln>
+        </p:spPr>
+      </p:pic>
+      <p:sp>
+        <p:nvSpPr>
+          <p:cNvPr id="23" name="TextBox 22"/>
           <p:cNvSpPr txBox="1"/>
           <p:nvPr/>
         </p:nvSpPr>
         <p:spPr>
           <a:xfrm>
-            <a:off x="4480560" y="1188720"/>
-            <a:ext cx="7132320" cy="4846320"/>
+            <a:off x="4206240" y="6035040"/>
+            <a:ext cx="3429521" cy="365760"/>
           </a:xfrm>
           <a:prstGeom prst="rect">
             <a:avLst/>
@@ -6133,6 +8335,44 @@
           </a:bodyPr>
           <a:lstStyle/>
           <a:p>
+            <a:pPr algn="ctr">
+              <a:spcAft>
+                <a:spcPts val="600"/>
+              </a:spcAft>
+            </a:pPr>
+            <a:r>
+              <a:rPr sz="1100" b="0">
+                <a:solidFill>
+                  <a:srgbClr val="5F7178"/>
+                </a:solidFill>
+              </a:rPr>
+              <a:t>Page 4: error mix, analyser performance, operators</a:t>
+            </a:r>
+          </a:p>
+        </p:txBody>
+      </p:sp>
+      <p:sp>
+        <p:nvSpPr>
+          <p:cNvPr id="24" name="TextBox 23"/>
+          <p:cNvSpPr txBox="1"/>
+          <p:nvPr/>
+        </p:nvSpPr>
+        <p:spPr>
+          <a:xfrm>
+            <a:off x="8046720" y="1188720"/>
+            <a:ext cx="3566160" cy="4846320"/>
+          </a:xfrm>
+          <a:prstGeom prst="rect">
+            <a:avLst/>
+          </a:prstGeom>
+          <a:noFill/>
+        </p:spPr>
+        <p:txBody>
+          <a:bodyPr wrap="square">
+            <a:spAutoFit/>
+          </a:bodyPr>
+          <a:lstStyle/>
+          <a:p>
             <a:pPr algn="l">
               <a:spcAft>
                 <a:spcPts val="600"/>
@@ -6144,7 +8384,7 @@
                   <a:srgbClr val="01485C"/>
                 </a:solidFill>
               </a:rPr>
-              <a:t>The four-month rule</a:t>
+              <a:t>Per analyser, then per operator</a:t>
             </a:r>
           </a:p>
           <a:p>
@@ -6159,7 +8399,7 @@
                   <a:srgbClr val="17272E"/>
                 </a:solidFill>
               </a:rPr>
-              <a:t>An analyser with no cartridges, no simulator runs and no ceramic cleaning for four consecutive months is dormant: it gets no report and no longer counts against its site’s checks.</a:t>
+              <a:t>Pages 3–4 repeat both charts for the second analyser, so each instrument’s twelve months are visible on their own.</a:t>
             </a:r>
           </a:p>
           <a:p>
@@ -6174,7 +8414,7 @@
                   <a:srgbClr val="17272E"/>
                 </a:solidFill>
               </a:rPr>
-              <a:t>One or two quiet months change nothing. The reports exist to catch wards skipping simulators, so nothing is removed early.</a:t>
+              <a:t>Analyzer Performance: total tests, total errors and error % per analyser with its band.</a:t>
             </a:r>
           </a:p>
           <a:p>
@@ -6189,29 +8429,14 @@
                   <a:srgbClr val="17272E"/>
                 </a:solidFill>
               </a:rPr>
-              <a:t>Any use brings the unit straight back the next month.</a:t>
-            </a:r>
-          </a:p>
-          <a:p>
-            <a:pPr algn="l">
-              <a:spcAft>
-                <a:spcPts val="600"/>
-              </a:spcAft>
-            </a:pPr>
-            <a:r>
-              <a:rPr sz="1200" b="0">
-                <a:solidFill>
-                  <a:srgbClr val="17272E"/>
-                </a:solidFill>
-              </a:rPr>
-              <a:t>Every run writes the list: hospital, location, serial, months idle and last activity. In August 2026, 163 units — mostly old models sitting beside their replacements — a ready-made retirement list.</a:t>
-            </a:r>
-          </a:p>
-        </p:txBody>
-      </p:sp>
-      <p:sp>
-        <p:nvSpPr>
-          <p:cNvPr id="23" name="TextBox 22"/>
+              <a:t>Operator Error Details by Analyzer: every operator on each analyser with tests run, a column per ABL error code (328–791), total errors and error %. Flagged operators — over 10% error with more than 10 tests — are in red; low-volume operators are marked and not assessed.</a:t>
+            </a:r>
+          </a:p>
+        </p:txBody>
+      </p:sp>
+      <p:sp>
+        <p:nvSpPr>
+          <p:cNvPr id="25" name="TextBox 24"/>
           <p:cNvSpPr txBox="1"/>
           <p:nvPr/>
         </p:nvSpPr>
@@ -6437,7 +8662,7 @@
                   <a:srgbClr val="01485C"/>
                 </a:solidFill>
               </a:rPr>
-              <a:t>How it protects the data</a:t>
+              <a:t>ABL — Townsville ED, August 2026 — page 5 of 5</a:t>
             </a:r>
           </a:p>
         </p:txBody>
@@ -6450,16 +8675,14 @@
         </p:nvSpPr>
         <p:spPr>
           <a:xfrm>
-            <a:off x="548640" y="1280160"/>
-            <a:ext cx="5440680" cy="2103120"/>
+            <a:off x="9784080" y="384048"/>
+            <a:ext cx="1828800" cy="457200"/>
           </a:xfrm>
           <a:prstGeom prst="roundRect">
-            <a:avLst>
-              <a:gd name="adj" fmla="val 8000"/>
-            </a:avLst>
-          </a:prstGeom>
-          <a:solidFill>
-            <a:srgbClr val="E5F2F0"/>
+            <a:avLst/>
+          </a:prstGeom>
+          <a:solidFill>
+            <a:srgbClr val="01485C"/>
           </a:solidFill>
           <a:ln>
             <a:noFill/>
@@ -6484,19 +8707,56 @@
           <a:lstStyle/>
           <a:p>
             <a:pPr algn="ctr"/>
-          </a:p>
-        </p:txBody>
-      </p:sp>
-      <p:sp>
-        <p:nvSpPr>
-          <p:cNvPr id="20" name="TextBox 19"/>
+            <a:r>
+              <a:rPr sz="1500" b="1">
+                <a:solidFill>
+                  <a:srgbClr val="FFFFFF"/>
+                </a:solidFill>
+              </a:rPr>
+              <a:t>i-STAT</a:t>
+            </a:r>
+          </a:p>
+        </p:txBody>
+      </p:sp>
+      <p:pic>
+        <p:nvPicPr>
+          <p:cNvPr id="20" name="Picture 19" descr="abl_dept_p5_top.png"/>
+          <p:cNvPicPr>
+            <a:picLocks noChangeAspect="1"/>
+          </p:cNvPicPr>
+          <p:nvPr/>
+        </p:nvPicPr>
+        <p:blipFill>
+          <a:blip r:embed="rId2"/>
+          <a:stretch>
+            <a:fillRect/>
+          </a:stretch>
+        </p:blipFill>
+        <p:spPr>
+          <a:xfrm>
+            <a:off x="548640" y="1143000"/>
+            <a:ext cx="7798985" cy="4846320"/>
+          </a:xfrm>
+          <a:prstGeom prst="rect">
+            <a:avLst/>
+          </a:prstGeom>
+          <a:ln>
+            <a:solidFill>
+              <a:srgbClr val="E2E8EA"/>
+            </a:solidFill>
+          </a:ln>
+        </p:spPr>
+      </p:pic>
+      <p:sp>
+        <p:nvSpPr>
+          <p:cNvPr id="21" name="TextBox 20"/>
           <p:cNvSpPr txBox="1"/>
           <p:nvPr/>
         </p:nvSpPr>
         <p:spPr>
           <a:xfrm>
-            <a:off x="777240" y="1417319"/>
-            <a:ext cx="4983480" cy="457200"/>
+            <a:off x="548640" y="6035040"/>
+            <a:ext cx="7798984" cy="365760"/>
           </a:xfrm>
           <a:prstGeom prst="rect">
             <a:avLst/>
@@ -6509,32 +8769,32 @@
           </a:bodyPr>
           <a:lstStyle/>
           <a:p>
-            <a:pPr algn="l">
-              <a:spcAft>
-                <a:spcPts val="600"/>
-              </a:spcAft>
-            </a:pPr>
-            <a:r>
-              <a:rPr sz="1500" b="1">
-                <a:solidFill>
-                  <a:srgbClr val="01485C"/>
-                </a:solidFill>
-              </a:rPr>
-              <a:t>Runs from an encrypted USB drive</a:t>
-            </a:r>
-          </a:p>
-        </p:txBody>
-      </p:sp>
-      <p:sp>
-        <p:nvSpPr>
-          <p:cNvPr id="21" name="TextBox 20"/>
+            <a:pPr algn="ctr">
+              <a:spcAft>
+                <a:spcPts val="600"/>
+              </a:spcAft>
+            </a:pPr>
+            <a:r>
+              <a:rPr sz="1100" b="0">
+                <a:solidFill>
+                  <a:srgbClr val="5F7178"/>
+                </a:solidFill>
+              </a:rPr>
+              <a:t>Page 5: error type summary and the 12-month review</a:t>
+            </a:r>
+          </a:p>
+        </p:txBody>
+      </p:sp>
+      <p:sp>
+        <p:nvSpPr>
+          <p:cNvPr id="22" name="TextBox 21"/>
           <p:cNvSpPr txBox="1"/>
           <p:nvPr/>
         </p:nvSpPr>
         <p:spPr>
           <a:xfrm>
-            <a:off x="777240" y="1847088"/>
-            <a:ext cx="4983480" cy="1463039"/>
+            <a:off x="8667664" y="1188720"/>
+            <a:ext cx="2945215" cy="4846320"/>
           </a:xfrm>
           <a:prstGeom prst="rect">
             <a:avLst/>
@@ -6553,420 +8813,64 @@
               </a:spcAft>
             </a:pPr>
             <a:r>
+              <a:rPr sz="1500" b="1">
+                <a:solidFill>
+                  <a:srgbClr val="01485C"/>
+                </a:solidFill>
+              </a:rPr>
+              <a:t>What the errors were, and who keeps appearing</a:t>
+            </a:r>
+          </a:p>
+          <a:p>
+            <a:pPr algn="l">
+              <a:spcAft>
+                <a:spcPts val="600"/>
+              </a:spcAft>
+            </a:pPr>
+            <a:r>
               <a:rPr sz="1200" b="0">
                 <a:solidFill>
                   <a:srgbClr val="17272E"/>
                 </a:solidFill>
               </a:rPr>
-              <a:t>Its own Python runtime, no installation, no admin rights, no changes to the PC. BitLocker To Go encrypts the whole drive.</a:t>
-            </a:r>
-          </a:p>
-        </p:txBody>
-      </p:sp>
-      <p:sp>
-        <p:nvSpPr>
-          <p:cNvPr id="22" name="Rounded Rectangle 21"/>
-          <p:cNvSpPr/>
-          <p:nvPr/>
-        </p:nvSpPr>
-        <p:spPr>
-          <a:xfrm>
-            <a:off x="6172200" y="1280160"/>
-            <a:ext cx="5440680" cy="2103120"/>
-          </a:xfrm>
-          <a:prstGeom prst="roundRect">
-            <a:avLst>
-              <a:gd name="adj" fmla="val 8000"/>
-            </a:avLst>
-          </a:prstGeom>
-          <a:solidFill>
-            <a:srgbClr val="E5F2F0"/>
-          </a:solidFill>
-          <a:ln>
-            <a:noFill/>
-          </a:ln>
-        </p:spPr>
-        <p:style>
-          <a:lnRef idx="1">
-            <a:schemeClr val="accent1"/>
-          </a:lnRef>
-          <a:fillRef idx="3">
-            <a:schemeClr val="accent1"/>
-          </a:fillRef>
-          <a:effectRef idx="2">
-            <a:schemeClr val="accent1"/>
-          </a:effectRef>
-          <a:fontRef idx="minor">
-            <a:schemeClr val="lt1"/>
-          </a:fontRef>
-        </p:style>
-        <p:txBody>
-          <a:bodyPr rtlCol="0" anchor="ctr"/>
-          <a:lstStyle/>
-          <a:p>
-            <a:pPr algn="ctr"/>
+              <a:t>Error Type Summary: the department’s count of each ABL error code for the month with its share of all errors — the department’s error fingerprint.</a:t>
+            </a:r>
+          </a:p>
+          <a:p>
+            <a:pPr algn="l">
+              <a:spcAft>
+                <a:spcPts val="600"/>
+              </a:spcAft>
+            </a:pPr>
+            <a:r>
+              <a:rPr sz="1200" b="0">
+                <a:solidFill>
+                  <a:srgbClr val="17272E"/>
+                </a:solidFill>
+              </a:rPr>
+              <a:t>Operators Requiring Review: the 12-month lookback — every operator flagged in two or more months, with each month’s error rate and error types. This is the list for a conversation, not a single bad month.</a:t>
+            </a:r>
+          </a:p>
+          <a:p>
+            <a:pPr algn="l">
+              <a:spcAft>
+                <a:spcPts val="600"/>
+              </a:spcAft>
+            </a:pPr>
+            <a:r>
+              <a:rPr sz="1200" b="0">
+                <a:solidFill>
+                  <a:srgbClr val="17272E"/>
+                </a:solidFill>
+              </a:rPr>
+              <a:t>Operator names in the ABL history are encrypted on the drive in the same way as the i-STAT history.</a:t>
+            </a:r>
           </a:p>
         </p:txBody>
       </p:sp>
       <p:sp>
         <p:nvSpPr>
           <p:cNvPr id="23" name="TextBox 22"/>
-          <p:cNvSpPr txBox="1"/>
-          <p:nvPr/>
-        </p:nvSpPr>
-        <p:spPr>
-          <a:xfrm>
-            <a:off x="6400800" y="1417319"/>
-            <a:ext cx="4983480" cy="457200"/>
-          </a:xfrm>
-          <a:prstGeom prst="rect">
-            <a:avLst/>
-          </a:prstGeom>
-          <a:noFill/>
-        </p:spPr>
-        <p:txBody>
-          <a:bodyPr wrap="square">
-            <a:spAutoFit/>
-          </a:bodyPr>
-          <a:lstStyle/>
-          <a:p>
-            <a:pPr algn="l">
-              <a:spcAft>
-                <a:spcPts val="600"/>
-              </a:spcAft>
-            </a:pPr>
-            <a:r>
-              <a:rPr sz="1500" b="1">
-                <a:solidFill>
-                  <a:srgbClr val="01485C"/>
-                </a:solidFill>
-              </a:rPr>
-              <a:t>Offline by enforcement</a:t>
-            </a:r>
-          </a:p>
-        </p:txBody>
-      </p:sp>
-      <p:sp>
-        <p:nvSpPr>
-          <p:cNvPr id="24" name="TextBox 23"/>
-          <p:cNvSpPr txBox="1"/>
-          <p:nvPr/>
-        </p:nvSpPr>
-        <p:spPr>
-          <a:xfrm>
-            <a:off x="6400800" y="1847088"/>
-            <a:ext cx="4983480" cy="1463039"/>
-          </a:xfrm>
-          <a:prstGeom prst="rect">
-            <a:avLst/>
-          </a:prstGeom>
-          <a:noFill/>
-        </p:spPr>
-        <p:txBody>
-          <a:bodyPr wrap="square">
-            <a:spAutoFit/>
-          </a:bodyPr>
-          <a:lstStyle/>
-          <a:p>
-            <a:pPr algn="l">
-              <a:spcAft>
-                <a:spcPts val="600"/>
-              </a:spcAft>
-            </a:pPr>
-            <a:r>
-              <a:rPr sz="1200" b="0">
-                <a:solidFill>
-                  <a:srgbClr val="17272E"/>
-                </a:solidFill>
-              </a:rPr>
-              <a:t>All three servers bind to the local machine only, and a runtime guard blocks and logs any attempt to reach the network. Zero outbound connections, ever.</a:t>
-            </a:r>
-          </a:p>
-        </p:txBody>
-      </p:sp>
-      <p:sp>
-        <p:nvSpPr>
-          <p:cNvPr id="25" name="Rounded Rectangle 24"/>
-          <p:cNvSpPr/>
-          <p:nvPr/>
-        </p:nvSpPr>
-        <p:spPr>
-          <a:xfrm>
-            <a:off x="548640" y="3566160"/>
-            <a:ext cx="5440680" cy="2103120"/>
-          </a:xfrm>
-          <a:prstGeom prst="roundRect">
-            <a:avLst>
-              <a:gd name="adj" fmla="val 8000"/>
-            </a:avLst>
-          </a:prstGeom>
-          <a:solidFill>
-            <a:srgbClr val="FDF0E4"/>
-          </a:solidFill>
-          <a:ln>
-            <a:noFill/>
-          </a:ln>
-        </p:spPr>
-        <p:style>
-          <a:lnRef idx="1">
-            <a:schemeClr val="accent1"/>
-          </a:lnRef>
-          <a:fillRef idx="3">
-            <a:schemeClr val="accent1"/>
-          </a:fillRef>
-          <a:effectRef idx="2">
-            <a:schemeClr val="accent1"/>
-          </a:effectRef>
-          <a:fontRef idx="minor">
-            <a:schemeClr val="lt1"/>
-          </a:fontRef>
-        </p:style>
-        <p:txBody>
-          <a:bodyPr rtlCol="0" anchor="ctr"/>
-          <a:lstStyle/>
-          <a:p>
-            <a:pPr algn="ctr"/>
-          </a:p>
-        </p:txBody>
-      </p:sp>
-      <p:sp>
-        <p:nvSpPr>
-          <p:cNvPr id="26" name="TextBox 25"/>
-          <p:cNvSpPr txBox="1"/>
-          <p:nvPr/>
-        </p:nvSpPr>
-        <p:spPr>
-          <a:xfrm>
-            <a:off x="777240" y="3703320"/>
-            <a:ext cx="4983480" cy="457200"/>
-          </a:xfrm>
-          <a:prstGeom prst="rect">
-            <a:avLst/>
-          </a:prstGeom>
-          <a:noFill/>
-        </p:spPr>
-        <p:txBody>
-          <a:bodyPr wrap="square">
-            <a:spAutoFit/>
-          </a:bodyPr>
-          <a:lstStyle/>
-          <a:p>
-            <a:pPr algn="l">
-              <a:spcAft>
-                <a:spcPts val="600"/>
-              </a:spcAft>
-            </a:pPr>
-            <a:r>
-              <a:rPr sz="1500" b="1">
-                <a:solidFill>
-                  <a:srgbClr val="B4540A"/>
-                </a:solidFill>
-              </a:rPr>
-              <a:t>Named staff data encrypted</a:t>
-            </a:r>
-          </a:p>
-        </p:txBody>
-      </p:sp>
-      <p:sp>
-        <p:nvSpPr>
-          <p:cNvPr id="27" name="TextBox 26"/>
-          <p:cNvSpPr txBox="1"/>
-          <p:nvPr/>
-        </p:nvSpPr>
-        <p:spPr>
-          <a:xfrm>
-            <a:off x="777240" y="4133087"/>
-            <a:ext cx="4983480" cy="1463039"/>
-          </a:xfrm>
-          <a:prstGeom prst="rect">
-            <a:avLst/>
-          </a:prstGeom>
-          <a:noFill/>
-        </p:spPr>
-        <p:txBody>
-          <a:bodyPr wrap="square">
-            <a:spAutoFit/>
-          </a:bodyPr>
-          <a:lstStyle/>
-          <a:p>
-            <a:pPr algn="l">
-              <a:spcAft>
-                <a:spcPts val="600"/>
-              </a:spcAft>
-            </a:pPr>
-            <a:r>
-              <a:rPr sz="1200" b="0">
-                <a:solidFill>
-                  <a:srgbClr val="17272E"/>
-                </a:solidFill>
-              </a:rPr>
-              <a:t>The rolling staff and device history is AES-encrypted with a password that is never stored. Reports cannot be generated until it is unlocked.</a:t>
-            </a:r>
-          </a:p>
-        </p:txBody>
-      </p:sp>
-      <p:sp>
-        <p:nvSpPr>
-          <p:cNvPr id="28" name="Rounded Rectangle 27"/>
-          <p:cNvSpPr/>
-          <p:nvPr/>
-        </p:nvSpPr>
-        <p:spPr>
-          <a:xfrm>
-            <a:off x="6172200" y="3566160"/>
-            <a:ext cx="5440680" cy="2103120"/>
-          </a:xfrm>
-          <a:prstGeom prst="roundRect">
-            <a:avLst>
-              <a:gd name="adj" fmla="val 8000"/>
-            </a:avLst>
-          </a:prstGeom>
-          <a:solidFill>
-            <a:srgbClr val="E5F2F0"/>
-          </a:solidFill>
-          <a:ln>
-            <a:noFill/>
-          </a:ln>
-        </p:spPr>
-        <p:style>
-          <a:lnRef idx="1">
-            <a:schemeClr val="accent1"/>
-          </a:lnRef>
-          <a:fillRef idx="3">
-            <a:schemeClr val="accent1"/>
-          </a:fillRef>
-          <a:effectRef idx="2">
-            <a:schemeClr val="accent1"/>
-          </a:effectRef>
-          <a:fontRef idx="minor">
-            <a:schemeClr val="lt1"/>
-          </a:fontRef>
-        </p:style>
-        <p:txBody>
-          <a:bodyPr rtlCol="0" anchor="ctr"/>
-          <a:lstStyle/>
-          <a:p>
-            <a:pPr algn="ctr"/>
-          </a:p>
-        </p:txBody>
-      </p:sp>
-      <p:sp>
-        <p:nvSpPr>
-          <p:cNvPr id="29" name="TextBox 28"/>
-          <p:cNvSpPr txBox="1"/>
-          <p:nvPr/>
-        </p:nvSpPr>
-        <p:spPr>
-          <a:xfrm>
-            <a:off x="6400800" y="3703320"/>
-            <a:ext cx="4983480" cy="457200"/>
-          </a:xfrm>
-          <a:prstGeom prst="rect">
-            <a:avLst/>
-          </a:prstGeom>
-          <a:noFill/>
-        </p:spPr>
-        <p:txBody>
-          <a:bodyPr wrap="square">
-            <a:spAutoFit/>
-          </a:bodyPr>
-          <a:lstStyle/>
-          <a:p>
-            <a:pPr algn="l">
-              <a:spcAft>
-                <a:spcPts val="600"/>
-              </a:spcAft>
-            </a:pPr>
-            <a:r>
-              <a:rPr sz="1500" b="1">
-                <a:solidFill>
-                  <a:srgbClr val="01485C"/>
-                </a:solidFill>
-              </a:rPr>
-              <a:t>Controlled roll-out</a:t>
-            </a:r>
-          </a:p>
-        </p:txBody>
-      </p:sp>
-      <p:sp>
-        <p:nvSpPr>
-          <p:cNvPr id="30" name="TextBox 29"/>
-          <p:cNvSpPr txBox="1"/>
-          <p:nvPr/>
-        </p:nvSpPr>
-        <p:spPr>
-          <a:xfrm>
-            <a:off x="6400800" y="4133087"/>
-            <a:ext cx="4983480" cy="1463039"/>
-          </a:xfrm>
-          <a:prstGeom prst="rect">
-            <a:avLst/>
-          </a:prstGeom>
-          <a:noFill/>
-        </p:spPr>
-        <p:txBody>
-          <a:bodyPr wrap="square">
-            <a:spAutoFit/>
-          </a:bodyPr>
-          <a:lstStyle/>
-          <a:p>
-            <a:pPr algn="l">
-              <a:spcAft>
-                <a:spcPts val="600"/>
-              </a:spcAft>
-            </a:pPr>
-            <a:r>
-              <a:rPr sz="1200" b="0">
-                <a:solidFill>
-                  <a:srgbClr val="17272E"/>
-                </a:solidFill>
-              </a:rPr>
-              <a:t>It runs only on PCs approved by the PoC lead, reviewed on the 12-month QIS cycle, with an audit trail of every launch and every report generated.</a:t>
-            </a:r>
-          </a:p>
-        </p:txBody>
-      </p:sp>
-      <p:sp>
-        <p:nvSpPr>
-          <p:cNvPr id="31" name="TextBox 30"/>
-          <p:cNvSpPr txBox="1"/>
-          <p:nvPr/>
-        </p:nvSpPr>
-        <p:spPr>
-          <a:xfrm>
-            <a:off x="548640" y="5806440"/>
-            <a:ext cx="11064240" cy="411480"/>
-          </a:xfrm>
-          <a:prstGeom prst="rect">
-            <a:avLst/>
-          </a:prstGeom>
-          <a:noFill/>
-        </p:spPr>
-        <p:txBody>
-          <a:bodyPr wrap="square">
-            <a:spAutoFit/>
-          </a:bodyPr>
-          <a:lstStyle/>
-          <a:p>
-            <a:pPr algn="l">
-              <a:spcAft>
-                <a:spcPts val="600"/>
-              </a:spcAft>
-            </a:pPr>
-            <a:r>
-              <a:rPr sz="1100" b="0">
-                <a:solidFill>
-                  <a:srgbClr val="5F7178"/>
-                </a:solidFill>
-              </a:rPr>
-              <a:t>Full detail for IT: SECURITY_README.md on the drive and the Security Briefing deck.</a:t>
-            </a:r>
-          </a:p>
-        </p:txBody>
-      </p:sp>
-      <p:sp>
-        <p:nvSpPr>
-          <p:cNvPr id="32" name="TextBox 31"/>
           <p:cNvSpPr txBox="1"/>
           <p:nvPr/>
         </p:nvSpPr>

</xml_diff>

<commit_message>
Manager deck: ABL slides carry the teal ABL badge
Co-Authored-By: Claude Fable 5.1 <noreply@anthropic.com>
</commit_message>
<xml_diff>
--- a/PQ_Report_Generator_Overview_for_Managers.pptx
+++ b/PQ_Report_Generator_Overview_for_Managers.pptx
@@ -1573,7 +1573,7 @@
             <a:avLst/>
           </a:prstGeom>
           <a:solidFill>
-            <a:srgbClr val="01485C"/>
+            <a:srgbClr val="11B5AE"/>
           </a:solidFill>
           <a:ln>
             <a:noFill/>
@@ -1604,7 +1604,7 @@
                   <a:srgbClr val="FFFFFF"/>
                 </a:solidFill>
               </a:rPr>
-              <a:t>i-STAT</a:t>
+              <a:t>ABL</a:t>
             </a:r>
           </a:p>
         </p:txBody>
@@ -7680,7 +7680,7 @@
             <a:avLst/>
           </a:prstGeom>
           <a:solidFill>
-            <a:srgbClr val="01485C"/>
+            <a:srgbClr val="11B5AE"/>
           </a:solidFill>
           <a:ln>
             <a:noFill/>
@@ -7711,7 +7711,7 @@
                   <a:srgbClr val="FFFFFF"/>
                 </a:solidFill>
               </a:rPr>
-              <a:t>i-STAT</a:t>
+              <a:t>ABL</a:t>
             </a:r>
           </a:p>
         </p:txBody>
@@ -8181,7 +8181,7 @@
             <a:avLst/>
           </a:prstGeom>
           <a:solidFill>
-            <a:srgbClr val="01485C"/>
+            <a:srgbClr val="11B5AE"/>
           </a:solidFill>
           <a:ln>
             <a:noFill/>
@@ -8212,7 +8212,7 @@
                   <a:srgbClr val="FFFFFF"/>
                 </a:solidFill>
               </a:rPr>
-              <a:t>i-STAT</a:t>
+              <a:t>ABL</a:t>
             </a:r>
           </a:p>
         </p:txBody>
@@ -8682,7 +8682,7 @@
             <a:avLst/>
           </a:prstGeom>
           <a:solidFill>
-            <a:srgbClr val="01485C"/>
+            <a:srgbClr val="11B5AE"/>
           </a:solidFill>
           <a:ln>
             <a:noFill/>
@@ -8713,7 +8713,7 @@
                   <a:srgbClr val="FFFFFF"/>
                 </a:solidFill>
               </a:rPr>
-              <a:t>i-STAT</a:t>
+              <a:t>ABL</a:t>
             </a:r>
           </a:p>
         </p:txBody>

</xml_diff>